<commit_message>
Sim-Review M02: 9 VPs umgesetzt + Artefakte neu + sim_review true
Co-Authored-By: Claude Fable 5 <noreply@anthropic.com>
</commit_message>
<xml_diff>
--- a/protected-downloads/praesentation/M02.pptx
+++ b/protected-downloads/praesentation/M02.pptx
@@ -6643,7 +6643,7 @@
                 </a:solidFill>
                 <a:latin typeface="Arial"/>
               </a:rPr>
-              <a:t>▸  Ein Bilanzgespräch mit einem KMU-Kunden anhand eines strukturierten 5-Phasen-Rahmens situativ planen und durchführen</a:t>
+              <a:t>▸  Ein Bilanzgespräch anhand eines strukturierten 5-Phasen-Rahmens situativ planen und durchführen</a:t>
             </a:r>
           </a:p>
           <a:p>
@@ -6662,7 +6662,7 @@
                 </a:solidFill>
                 <a:latin typeface="Arial"/>
               </a:rPr>
-              <a:t>▸  Kritische Kennzahlenentwicklungen im Kundendialog differenziert einordnen und gezielte Analysefragen stellen</a:t>
+              <a:t>▸  Kritische Kennzahlenentwicklungen im Kundendialog differenziert einordnen und Analysefragen stellen, ohne eine Abwehrhaltung auszulösen</a:t>
             </a:r>
           </a:p>
           <a:p>
@@ -6700,7 +6700,26 @@
                 </a:solidFill>
                 <a:latin typeface="Arial"/>
               </a:rPr>
-              <a:t>▸  Einwände konstruktiv aufgreifen und das Gespräch produktiv weiterführen</a:t>
+              <a:t>▸  Einwände mit Fragetechniken konstruktiv aufgreifen und das Gespräch weiterführen</a:t>
+            </a:r>
+          </a:p>
+          <a:p>
+            <a:pPr>
+              <a:spcBef>
+                <a:spcPts val="800"/>
+              </a:spcBef>
+              <a:spcAft>
+                <a:spcPts val="200"/>
+              </a:spcAft>
+            </a:pPr>
+            <a:r>
+              <a:rPr sz="1400">
+                <a:solidFill>
+                  <a:srgbClr val="3D5466"/>
+                </a:solidFill>
+                <a:latin typeface="Arial"/>
+              </a:rPr>
+              <a:t>▸  Aus der Bilanzanalyse bedarfsorientierte Beratungsimpulse für Verbundprodukte ableiten (DZ BANK, R+V, Union Investment, VR-Leasing)</a:t>
             </a:r>
           </a:p>
         </p:txBody>

</xml_diff>

<commit_message>
M-Track Batch 3: M02 Deck (Web/Workbook)
Co-Authored-By: Claude Fable 5 <noreply@anthropic.com>
</commit_message>
<xml_diff>
--- a/protected-downloads/praesentation/M02.pptx
+++ b/protected-downloads/praesentation/M02.pptx
@@ -17,6 +17,7 @@
     <p:sldId id="265" r:id="rId17"/>
     <p:sldId id="266" r:id="rId18"/>
     <p:sldId id="267" r:id="rId19"/>
+    <p:sldId id="268" r:id="rId20"/>
   </p:sldIdLst>
   <p:sldSz cx="12188952" cy="6858000" type="screen4x3"/>
   <p:notesSz cx="6858000" cy="9144000"/>
@@ -583,7 +584,7 @@
           <a:lstStyle/>
           <a:p>
             <a:r>
-              <a:t>Siehe Trainerhandbuch (Sektion 3) für Moderationshinweise, Timing und erwartete Teilnehmerreaktionen.</a:t>
+              <a:t>Einstieg: „Wie reagiert Ihr Kunde, wenn Sie eine schlechte Kennzahl ansprechen – und wie liegt das an der Formulierung?"</a:t>
             </a:r>
           </a:p>
         </p:txBody>
@@ -653,7 +654,7 @@
           <a:lstStyle/>
           <a:p>
             <a:r>
-              <a:t>Trainer-Hinweis (nur für Trainer und GF-Rolle sichtbar): Martin Klemm hat einen Großauftrag über 1,2 Mio. EUR an Land gezogen, der die Vorlauffinanzierung belastet. Zusätzlich lief eine CNC-Maschine (400 TEUR) aus dem Eigenkapital. Die Auftragslage ist gut, der Cash-Engpass temporär. Diese Infos gibt der GF nur preis, wenn der Berater konkret und respektvoll danach fragt – nie freiwillig.</a:t>
+              <a:t>Wer nur Zahlen vorträgt, löst Rechtfertigung aus; wer fragt, löst Erklärung aus.</a:t>
             </a:r>
           </a:p>
         </p:txBody>
@@ -723,7 +724,12 @@
           <a:lstStyle/>
           <a:p>
             <a:r>
-              <a:t>Siehe Trainerhandbuch (Sektion 3) für Moderationshinweise, Timing und erwartete Teilnehmerreaktionen.</a:t>
+              <a:t>Fragetechniken je Phase: offene Fragen zur Analyse, hypothetische Fragen im Lösungsraum.</a:t>
+            </a:r>
+          </a:p>
+          <a:p>
+            <a:r>
+              <a:t>Moderation (HB Sec 3): Theorie-Input II (min 35–50) Trainer-Hinweis: Stellen Sie beim Input II explizit klar: „Der 5-Phasen-Rahmen gibt Ihnen eine Struktur – im echten Gespräch dauert das Ganze 60 bis 75 Minuten, nicht 180. Was wir heute im Seminar üben, ist die Qualität jeder Phase, nicht die Länge." So vermeiden Sie den (in der Praxis häufigen) Eindruck, ein Bilanzgespräch müsse drei Stunden dauern. Rollenspiel-Einstieg (min 50–65) Trainer-Hinweis: Viele Teilnehmer empfinden Rollenspiele als unangenehm. Normalisieren Sie das explizit: „Rollenspiele sind seltsam – das ist normal." Betonen Sie, dass Beobachter eine aktive, wertvolle Rolle haben. Das Ziel ist nicht Perfektion, sondern das Ausprobieren. Umgang mit Widerstand im Rollenspiel Trainer-Tipp: Nutzen Sie die „Freeze-Technik": Rufen Sie während eines Rollenspiels „Freeze!" – alle frieren ein. Fragen Sie den Berater: „Was überlegen Sie gerade? Welche Frage könnten Sie jetzt stellen?" Dann weiter. Diese Methode erhöht die Reflexionstiefe. Debriefing-Struktur (min 95–115 und 155–170) Trainer-Hinweis: Strukturieren Sie das Debriefing immer in dieser Reihenfolge: (1) Beschreibung – Was ist passiert? (2) Analyse – Warum? (3) Generalisierung – Was lernen wir? (4) Transfer – Was mache ich nächste Woche? Schweigen aushalten: 15 Sekunden Stille nach einer Frage sind produktiv. Trainer-Hinweis (gemischte Erfahrungsstufen): Wenn erfahrene Teilnehmer im Debriefing Fragen in Richtung M03 oder regulatorischer Konsequenzen (§ 18 KWG, Grenze des Gesprächs) stellen: Diese kurz beantworten, dann explizit zurückschalten: „Das ist eine wichtige Frage – die vertiefen wir in M03. Für heute: Was nehmen die mit uns, die vielleicht noch kein Bilanzgespräch mit dieser Komplexität hatten?" Damit holen Sie unerfahrene TN aktiv zurück in den Dialog, statt sie durch Spezialdiskussionen zu verlieren. Transfer-Vorsatz (min 170–175) Trainer-Hinweis: Der Transfer-Vorsatz muss konkret und verhaltensbasiert sein – nicht „Ich möchte besser zuhören", sondern „Ich werde beim nächsten Gespräch mit Müller GmbH mindestens eine Implikationsfrage stellen." Notieren Sie alle Vorsätze auf Flipchart. Empfehlen Sie den TN, sofort nach dem Seminar (spätestens heute) eine agree-Wiedervorlage auf 4 Wochen zu setzen – so wird aus dem Vorsatz ein institutionell verankerter Termin statt eines „Ehrensystems".</a:t>
             </a:r>
           </a:p>
         </p:txBody>
@@ -793,7 +799,147 @@
           <a:lstStyle/>
           <a:p>
             <a:r>
-              <a:t>Siehe Trainerhandbuch (Sektion 3) für Moderationshinweise, Timing und erwartete Teilnehmerreaktionen.</a:t>
+              <a:t>Schwäbische Metallbau: kritische Kennzahlen auffällig – die Kunst ist, sie als Frage einzubringen. Debriefing: Wann kippte das Gespräch in Rechtfertigung?</a:t>
+            </a:r>
+          </a:p>
+        </p:txBody>
+      </p:sp>
+      <p:sp>
+        <p:nvSpPr>
+          <p:cNvPr id="4" name="Slide Number Placeholder 3"/>
+          <p:cNvSpPr>
+            <a:spLocks noGrp="1"/>
+          </p:cNvSpPr>
+          <p:nvPr>
+            <p:ph type="sldNum" idx="5" sz="quarter"/>
+          </p:nvPr>
+        </p:nvSpPr>
+        <p:spPr/>
+      </p:sp>
+    </p:spTree>
+  </p:cSld>
+  <p:clrMapOvr>
+    <a:masterClrMapping/>
+  </p:clrMapOvr>
+</p:notes>
+</file>
+
+<file path=ppt/notesSlides/notesSlide6.xml><?xml version="1.0" encoding="utf-8"?>
+<p:notes xmlns:a="http://schemas.openxmlformats.org/drawingml/2006/main" xmlns:p="http://schemas.openxmlformats.org/presentationml/2006/main" xmlns:r="http://schemas.openxmlformats.org/officeDocument/2006/relationships">
+  <p:cSld>
+    <p:spTree>
+      <p:nvGrpSpPr>
+        <p:cNvPr id="1" name=""/>
+        <p:cNvGrpSpPr/>
+        <p:nvPr/>
+      </p:nvGrpSpPr>
+      <p:grpSpPr>
+        <a:xfrm>
+          <a:off x="0" y="0"/>
+          <a:ext cx="0" cy="0"/>
+          <a:chOff x="0" y="0"/>
+          <a:chExt cx="0" cy="0"/>
+        </a:xfrm>
+      </p:grpSpPr>
+      <p:sp>
+        <p:nvSpPr>
+          <p:cNvPr id="2" name="Slide Image Placeholder 1"/>
+          <p:cNvSpPr>
+            <a:spLocks noGrp="1"/>
+          </p:cNvSpPr>
+          <p:nvPr>
+            <p:ph type="sldImg" idx="2"/>
+          </p:nvPr>
+        </p:nvSpPr>
+        <p:spPr/>
+      </p:sp>
+      <p:sp>
+        <p:nvSpPr>
+          <p:cNvPr id="3" name="Notes Placeholder 2"/>
+          <p:cNvSpPr>
+            <a:spLocks noGrp="1"/>
+          </p:cNvSpPr>
+          <p:nvPr>
+            <p:ph type="body" idx="3" sz="quarter"/>
+          </p:nvPr>
+        </p:nvSpPr>
+        <p:spPr/>
+        <p:txBody>
+          <a:bodyPr/>
+          <a:lstStyle/>
+          <a:p>
+            <a:r>
+              <a:t>Überleitung zum Selbstcheck.</a:t>
+            </a:r>
+          </a:p>
+        </p:txBody>
+      </p:sp>
+      <p:sp>
+        <p:nvSpPr>
+          <p:cNvPr id="4" name="Slide Number Placeholder 3"/>
+          <p:cNvSpPr>
+            <a:spLocks noGrp="1"/>
+          </p:cNvSpPr>
+          <p:nvPr>
+            <p:ph type="sldNum" idx="5" sz="quarter"/>
+          </p:nvPr>
+        </p:nvSpPr>
+        <p:spPr/>
+      </p:sp>
+    </p:spTree>
+  </p:cSld>
+  <p:clrMapOvr>
+    <a:masterClrMapping/>
+  </p:clrMapOvr>
+</p:notes>
+</file>
+
+<file path=ppt/notesSlides/notesSlide7.xml><?xml version="1.0" encoding="utf-8"?>
+<p:notes xmlns:a="http://schemas.openxmlformats.org/drawingml/2006/main" xmlns:p="http://schemas.openxmlformats.org/presentationml/2006/main" xmlns:r="http://schemas.openxmlformats.org/officeDocument/2006/relationships">
+  <p:cSld>
+    <p:spTree>
+      <p:nvGrpSpPr>
+        <p:cNvPr id="1" name=""/>
+        <p:cNvGrpSpPr/>
+        <p:nvPr/>
+      </p:nvGrpSpPr>
+      <p:grpSpPr>
+        <a:xfrm>
+          <a:off x="0" y="0"/>
+          <a:ext cx="0" cy="0"/>
+          <a:chOff x="0" y="0"/>
+          <a:chExt cx="0" cy="0"/>
+        </a:xfrm>
+      </p:grpSpPr>
+      <p:sp>
+        <p:nvSpPr>
+          <p:cNvPr id="2" name="Slide Image Placeholder 1"/>
+          <p:cNvSpPr>
+            <a:spLocks noGrp="1"/>
+          </p:cNvSpPr>
+          <p:nvPr>
+            <p:ph type="sldImg" idx="2"/>
+          </p:nvPr>
+        </p:nvSpPr>
+        <p:spPr/>
+      </p:sp>
+      <p:sp>
+        <p:nvSpPr>
+          <p:cNvPr id="3" name="Notes Placeholder 2"/>
+          <p:cNvSpPr>
+            <a:spLocks noGrp="1"/>
+          </p:cNvSpPr>
+          <p:nvPr>
+            <p:ph type="body" idx="3" sz="quarter"/>
+          </p:nvPr>
+        </p:nvSpPr>
+        <p:spPr/>
+        <p:txBody>
+          <a:bodyPr/>
+          <a:lstStyle/>
+          <a:p>
+            <a:r>
+              <a:t>Selbstcheck nach 4 Wochen als Transferanker.</a:t>
             </a:r>
           </a:p>
         </p:txBody>
@@ -4389,7 +4535,7 @@
             <a:avLst/>
           </a:prstGeom>
           <a:solidFill>
-            <a:srgbClr val="FFFFFF"/>
+            <a:srgbClr val="1F2C56"/>
           </a:solidFill>
           <a:ln>
             <a:noFill/>
@@ -4419,57 +4565,14 @@
       </p:sp>
       <p:sp>
         <p:nvSpPr>
-          <p:cNvPr id="3" name="Rectangle 2"/>
-          <p:cNvSpPr/>
-          <p:nvPr/>
-        </p:nvSpPr>
-        <p:spPr>
-          <a:xfrm>
-            <a:off x="0" y="0"/>
-            <a:ext cx="12188952" cy="50292"/>
-          </a:xfrm>
-          <a:prstGeom prst="rect">
-            <a:avLst/>
-          </a:prstGeom>
-          <a:solidFill>
-            <a:srgbClr val="1F2C56"/>
-          </a:solidFill>
-          <a:ln>
-            <a:noFill/>
-          </a:ln>
-        </p:spPr>
-        <p:style>
-          <a:lnRef idx="1">
-            <a:schemeClr val="accent1"/>
-          </a:lnRef>
-          <a:fillRef idx="3">
-            <a:schemeClr val="accent1"/>
-          </a:fillRef>
-          <a:effectRef idx="2">
-            <a:schemeClr val="accent1"/>
-          </a:effectRef>
-          <a:fontRef idx="minor">
-            <a:schemeClr val="lt1"/>
-          </a:fontRef>
-        </p:style>
-        <p:txBody>
-          <a:bodyPr rtlCol="0" anchor="ctr"/>
-          <a:lstStyle/>
-          <a:p>
-            <a:pPr algn="ctr"/>
-          </a:p>
-        </p:txBody>
-      </p:sp>
-      <p:sp>
-        <p:nvSpPr>
-          <p:cNvPr id="4" name="TextBox 3"/>
+          <p:cNvPr id="3" name="TextBox 2"/>
           <p:cNvSpPr txBox="1"/>
           <p:nvPr/>
         </p:nvSpPr>
         <p:spPr>
           <a:xfrm>
-            <a:off x="685800" y="109728"/>
-            <a:ext cx="10817352" cy="228600"/>
+            <a:off x="685800" y="2377440"/>
+            <a:ext cx="10817352" cy="365760"/>
           </a:xfrm>
           <a:prstGeom prst="rect">
             <a:avLst/>
@@ -4484,62 +4587,27 @@
           <a:p>
             <a:pPr algn="l"/>
             <a:r>
-              <a:rPr sz="750">
-                <a:solidFill>
-                  <a:srgbClr val="78808C"/>
+              <a:rPr sz="1200">
+                <a:solidFill>
+                  <a:srgbClr val="D9C089"/>
                 </a:solidFill>
                 <a:latin typeface="Consolas"/>
               </a:rPr>
-              <a:t>M02  ·  ÜBERSICHT</a:t>
-            </a:r>
-          </a:p>
-        </p:txBody>
-      </p:sp>
-      <p:sp>
-        <p:nvSpPr>
-          <p:cNvPr id="5" name="TextBox 4"/>
-          <p:cNvSpPr txBox="1"/>
-          <p:nvPr/>
-        </p:nvSpPr>
-        <p:spPr>
-          <a:xfrm>
-            <a:off x="685800" y="502920"/>
-            <a:ext cx="10817352" cy="594360"/>
-          </a:xfrm>
-          <a:prstGeom prst="rect">
-            <a:avLst/>
-          </a:prstGeom>
-          <a:noFill/>
-        </p:spPr>
-        <p:txBody>
-          <a:bodyPr wrap="square">
-            <a:spAutoFit/>
-          </a:bodyPr>
-          <a:lstStyle/>
-          <a:p>
-            <a:pPr algn="l"/>
-            <a:r>
-              <a:rPr sz="2000" b="1" i="0">
-                <a:solidFill>
-                  <a:srgbClr val="1F2C56"/>
-                </a:solidFill>
-                <a:latin typeface="Arial"/>
-              </a:rPr>
-              <a:t>Praxiscase: Schwäbische Metallbau GmbH</a:t>
-            </a:r>
-          </a:p>
-        </p:txBody>
-      </p:sp>
-      <p:sp>
-        <p:nvSpPr>
-          <p:cNvPr id="6" name="Rectangle 5"/>
+              <a:t>FALLARBEIT</a:t>
+            </a:r>
+          </a:p>
+        </p:txBody>
+      </p:sp>
+      <p:sp>
+        <p:nvSpPr>
+          <p:cNvPr id="4" name="Rectangle 3"/>
           <p:cNvSpPr/>
           <p:nvPr/>
         </p:nvSpPr>
         <p:spPr>
           <a:xfrm>
-            <a:off x="685800" y="1143000"/>
-            <a:ext cx="10817352" cy="25400"/>
+            <a:off x="685800" y="2788920"/>
+            <a:ext cx="548640" cy="38100"/>
           </a:xfrm>
           <a:prstGeom prst="rect">
             <a:avLst/>
@@ -4573,370 +4641,86 @@
           </a:p>
         </p:txBody>
       </p:sp>
-      <p:graphicFrame>
-        <p:nvGraphicFramePr>
-          <p:cNvPr id="7" name="Table 6"/>
-          <p:cNvGraphicFramePr>
-            <a:graphicFrameLocks noGrp="1"/>
-          </p:cNvGraphicFramePr>
-          <p:nvPr/>
-        </p:nvGraphicFramePr>
-        <p:xfrm>
-          <a:off x="685800" y="1417320"/>
-          <a:ext cx="10817352" cy="2688336"/>
-        </p:xfrm>
-        <a:graphic>
-          <a:graphicData uri="http://schemas.openxmlformats.org/drawingml/2006/table">
-            <a:tbl>
-              <a:tblPr firstRow="1" bandRow="1">
-                <a:tableStyleId>{5C22544A-7EE6-4342-B048-85BDC9FD1C3A}</a:tableStyleId>
-              </a:tblPr>
-              <a:tblGrid>
-                <a:gridCol w="3605784"/>
-                <a:gridCol w="3605784"/>
-                <a:gridCol w="3605784"/>
-              </a:tblGrid>
-              <a:tr h="384048">
-                <a:tc>
-                  <a:txBody>
-                    <a:bodyPr/>
-                    <a:lstStyle/>
-                    <a:p>
-                      <a:r>
-                        <a:rPr sz="1100" b="1">
-                          <a:solidFill>
-                            <a:srgbClr val="FFFFFF"/>
-                          </a:solidFill>
-                          <a:latin typeface="Arial"/>
-                        </a:rPr>
-                        <a:t>Kriterium</a:t>
-                      </a:r>
-                    </a:p>
-                  </a:txBody>
-                  <a:tcPr>
-                    <a:solidFill>
-                      <a:srgbClr val="1F2C56"/>
-                    </a:solidFill>
-                  </a:tcPr>
-                </a:tc>
-                <a:tc>
-                  <a:txBody>
-                    <a:bodyPr/>
-                    <a:lstStyle/>
-                    <a:p>
-                      <a:r>
-                        <a:rPr sz="1100" b="1">
-                          <a:solidFill>
-                            <a:srgbClr val="FFFFFF"/>
-                          </a:solidFill>
-                          <a:latin typeface="Arial"/>
-                        </a:rPr>
-                        <a:t>Beobachtung / Beispiel</a:t>
-                      </a:r>
-                    </a:p>
-                  </a:txBody>
-                  <a:tcPr>
-                    <a:solidFill>
-                      <a:srgbClr val="1F2C56"/>
-                    </a:solidFill>
-                  </a:tcPr>
-                </a:tc>
-                <a:tc>
-                  <a:txBody>
-                    <a:bodyPr/>
-                    <a:lstStyle/>
-                    <a:p>
-                      <a:r>
-                        <a:rPr sz="1100" b="1">
-                          <a:solidFill>
-                            <a:srgbClr val="FFFFFF"/>
-                          </a:solidFill>
-                          <a:latin typeface="Arial"/>
-                        </a:rPr>
-                        <a:t>1–5</a:t>
-                      </a:r>
-                    </a:p>
-                  </a:txBody>
-                  <a:tcPr>
-                    <a:solidFill>
-                      <a:srgbClr val="1F2C56"/>
-                    </a:solidFill>
-                  </a:tcPr>
-                </a:tc>
-              </a:tr>
-              <a:tr h="384048">
-                <a:tc>
-                  <a:txBody>
-                    <a:bodyPr/>
-                    <a:lstStyle/>
-                    <a:p>
-                      <a:r>
-                        <a:rPr sz="1050">
-                          <a:solidFill>
-                            <a:srgbClr val="3D5466"/>
-                          </a:solidFill>
-                          <a:latin typeface="Arial"/>
-                        </a:rPr>
-                        <a:t>5-Phasen-Rahmen eingehalten</a:t>
-                      </a:r>
-                    </a:p>
-                  </a:txBody>
-                  <a:tcPr/>
-                </a:tc>
-                <a:tc>
-                  <a:txBody>
-                    <a:bodyPr/>
-                    <a:lstStyle/>
-                    <a:p/>
-                  </a:txBody>
-                  <a:tcPr/>
-                </a:tc>
-                <a:tc>
-                  <a:txBody>
-                    <a:bodyPr/>
-                    <a:lstStyle/>
-                    <a:p/>
-                  </a:txBody>
-                  <a:tcPr/>
-                </a:tc>
-              </a:tr>
-              <a:tr h="384048">
-                <a:tc>
-                  <a:txBody>
-                    <a:bodyPr/>
-                    <a:lstStyle/>
-                    <a:p>
-                      <a:r>
-                        <a:rPr sz="1050">
-                          <a:solidFill>
-                            <a:srgbClr val="3D5466"/>
-                          </a:solidFill>
-                          <a:latin typeface="Arial"/>
-                        </a:rPr>
-                        <a:t>Offene Fragen eingesetzt</a:t>
-                      </a:r>
-                    </a:p>
-                  </a:txBody>
-                  <a:tcPr/>
-                </a:tc>
-                <a:tc>
-                  <a:txBody>
-                    <a:bodyPr/>
-                    <a:lstStyle/>
-                    <a:p/>
-                  </a:txBody>
-                  <a:tcPr/>
-                </a:tc>
-                <a:tc>
-                  <a:txBody>
-                    <a:bodyPr/>
-                    <a:lstStyle/>
-                    <a:p/>
-                  </a:txBody>
-                  <a:tcPr/>
-                </a:tc>
-              </a:tr>
-              <a:tr h="384048">
-                <a:tc>
-                  <a:txBody>
-                    <a:bodyPr/>
-                    <a:lstStyle/>
-                    <a:p>
-                      <a:r>
-                        <a:rPr sz="1050">
-                          <a:solidFill>
-                            <a:srgbClr val="3D5466"/>
-                          </a:solidFill>
-                          <a:latin typeface="Arial"/>
-                        </a:rPr>
-                        <a:t>Beobachtung + Frage statt Beobachtung + Urteil</a:t>
-                      </a:r>
-                    </a:p>
-                  </a:txBody>
-                  <a:tcPr/>
-                </a:tc>
-                <a:tc>
-                  <a:txBody>
-                    <a:bodyPr/>
-                    <a:lstStyle/>
-                    <a:p/>
-                  </a:txBody>
-                  <a:tcPr/>
-                </a:tc>
-                <a:tc>
-                  <a:txBody>
-                    <a:bodyPr/>
-                    <a:lstStyle/>
-                    <a:p/>
-                  </a:txBody>
-                  <a:tcPr/>
-                </a:tc>
-              </a:tr>
-              <a:tr h="384048">
-                <a:tc>
-                  <a:txBody>
-                    <a:bodyPr/>
-                    <a:lstStyle/>
-                    <a:p>
-                      <a:r>
-                        <a:rPr sz="1050">
-                          <a:solidFill>
-                            <a:srgbClr val="3D5466"/>
-                          </a:solidFill>
-                          <a:latin typeface="Arial"/>
-                        </a:rPr>
-                        <a:t>Qualitative Info aktiv erfragt</a:t>
-                      </a:r>
-                    </a:p>
-                  </a:txBody>
-                  <a:tcPr/>
-                </a:tc>
-                <a:tc>
-                  <a:txBody>
-                    <a:bodyPr/>
-                    <a:lstStyle/>
-                    <a:p/>
-                  </a:txBody>
-                  <a:tcPr/>
-                </a:tc>
-                <a:tc>
-                  <a:txBody>
-                    <a:bodyPr/>
-                    <a:lstStyle/>
-                    <a:p/>
-                  </a:txBody>
-                  <a:tcPr/>
-                </a:tc>
-              </a:tr>
-              <a:tr h="384048">
-                <a:tc>
-                  <a:txBody>
-                    <a:bodyPr/>
-                    <a:lstStyle/>
-                    <a:p>
-                      <a:r>
-                        <a:rPr sz="1050">
-                          <a:solidFill>
-                            <a:srgbClr val="3D5466"/>
-                          </a:solidFill>
-                          <a:latin typeface="Arial"/>
-                        </a:rPr>
-                        <a:t>Konkrete Beratungsimpulse aus Analyse abgeleitet</a:t>
-                      </a:r>
-                    </a:p>
-                  </a:txBody>
-                  <a:tcPr/>
-                </a:tc>
-                <a:tc>
-                  <a:txBody>
-                    <a:bodyPr/>
-                    <a:lstStyle/>
-                    <a:p/>
-                  </a:txBody>
-                  <a:tcPr/>
-                </a:tc>
-                <a:tc>
-                  <a:txBody>
-                    <a:bodyPr/>
-                    <a:lstStyle/>
-                    <a:p/>
-                  </a:txBody>
-                  <a:tcPr/>
-                </a:tc>
-              </a:tr>
-              <a:tr h="384048">
-                <a:tc>
-                  <a:txBody>
-                    <a:bodyPr/>
-                    <a:lstStyle/>
-                    <a:p>
-                      <a:r>
-                        <a:rPr sz="1050">
-                          <a:solidFill>
-                            <a:srgbClr val="3D5466"/>
-                          </a:solidFill>
-                          <a:latin typeface="Arial"/>
-                        </a:rPr>
-                        <a:t>Gespräch wirkte wie Dialog auf Augenhöhe</a:t>
-                      </a:r>
-                    </a:p>
-                  </a:txBody>
-                  <a:tcPr/>
-                </a:tc>
-                <a:tc>
-                  <a:txBody>
-                    <a:bodyPr/>
-                    <a:lstStyle/>
-                    <a:p/>
-                  </a:txBody>
-                  <a:tcPr/>
-                </a:tc>
-                <a:tc>
-                  <a:txBody>
-                    <a:bodyPr/>
-                    <a:lstStyle/>
-                    <a:p/>
-                  </a:txBody>
-                  <a:tcPr/>
-                </a:tc>
-              </a:tr>
-            </a:tbl>
-          </a:graphicData>
-        </a:graphic>
-      </p:graphicFrame>
-      <p:sp>
-        <p:nvSpPr>
-          <p:cNvPr id="8" name="Rectangle 7"/>
-          <p:cNvSpPr/>
-          <p:nvPr/>
-        </p:nvSpPr>
-        <p:spPr>
-          <a:xfrm>
-            <a:off x="0" y="6510528"/>
-            <a:ext cx="12188952" cy="347472"/>
-          </a:xfrm>
-          <a:prstGeom prst="rect">
-            <a:avLst/>
-          </a:prstGeom>
-          <a:solidFill>
-            <a:srgbClr val="0A1937"/>
-          </a:solidFill>
-          <a:ln>
-            <a:noFill/>
-          </a:ln>
-        </p:spPr>
-        <p:style>
-          <a:lnRef idx="1">
-            <a:schemeClr val="accent1"/>
-          </a:lnRef>
-          <a:fillRef idx="3">
-            <a:schemeClr val="accent1"/>
-          </a:fillRef>
-          <a:effectRef idx="2">
-            <a:schemeClr val="accent1"/>
-          </a:effectRef>
-          <a:fontRef idx="minor">
-            <a:schemeClr val="lt1"/>
-          </a:fontRef>
-        </p:style>
-        <p:txBody>
-          <a:bodyPr rtlCol="0" anchor="ctr"/>
-          <a:lstStyle/>
-          <a:p>
-            <a:pPr algn="ctr"/>
-          </a:p>
-        </p:txBody>
-      </p:sp>
-      <p:sp>
-        <p:nvSpPr>
-          <p:cNvPr id="9" name="TextBox 8"/>
+      <p:sp>
+        <p:nvSpPr>
+          <p:cNvPr id="5" name="TextBox 4"/>
           <p:cNvSpPr txBox="1"/>
           <p:nvPr/>
         </p:nvSpPr>
         <p:spPr>
           <a:xfrm>
-            <a:off x="685800" y="6583680"/>
-            <a:ext cx="6490411" cy="256032"/>
+            <a:off x="685800" y="3017520"/>
+            <a:ext cx="10817352" cy="1463040"/>
+          </a:xfrm>
+          <a:prstGeom prst="rect">
+            <a:avLst/>
+          </a:prstGeom>
+          <a:noFill/>
+        </p:spPr>
+        <p:txBody>
+          <a:bodyPr wrap="square">
+            <a:spAutoFit/>
+          </a:bodyPr>
+          <a:lstStyle/>
+          <a:p>
+            <a:pPr algn="l"/>
+            <a:r>
+              <a:rPr sz="4000" b="1" i="0">
+                <a:solidFill>
+                  <a:srgbClr val="FFFFFF"/>
+                </a:solidFill>
+                <a:latin typeface="Arial"/>
+              </a:rPr>
+              <a:t>Praxiscase &amp; Rollenspiel</a:t>
+            </a:r>
+          </a:p>
+        </p:txBody>
+      </p:sp>
+      <p:sp>
+        <p:nvSpPr>
+          <p:cNvPr id="6" name="TextBox 5"/>
+          <p:cNvSpPr txBox="1"/>
+          <p:nvPr/>
+        </p:nvSpPr>
+        <p:spPr>
+          <a:xfrm>
+            <a:off x="685800" y="4480560"/>
+            <a:ext cx="8653881" cy="1280160"/>
+          </a:xfrm>
+          <a:prstGeom prst="rect">
+            <a:avLst/>
+          </a:prstGeom>
+          <a:noFill/>
+        </p:spPr>
+        <p:txBody>
+          <a:bodyPr wrap="square">
+            <a:spAutoFit/>
+          </a:bodyPr>
+          <a:lstStyle/>
+          <a:p>
+            <a:pPr algn="l"/>
+            <a:r>
+              <a:rPr sz="1600" b="0" i="0">
+                <a:solidFill>
+                  <a:srgbClr val="C8D2E6"/>
+                </a:solidFill>
+                <a:latin typeface="Arial"/>
+              </a:rPr>
+              <a:t>Ein kritisches Bilanzgespräch vorbereiten und im Rollenspiel führen.</a:t>
+            </a:r>
+          </a:p>
+        </p:txBody>
+      </p:sp>
+      <p:sp>
+        <p:nvSpPr>
+          <p:cNvPr id="7" name="TextBox 6"/>
+          <p:cNvSpPr txBox="1"/>
+          <p:nvPr/>
+        </p:nvSpPr>
+        <p:spPr>
+          <a:xfrm>
+            <a:off x="685800" y="6355080"/>
+            <a:ext cx="10817352" cy="274320"/>
           </a:xfrm>
           <a:prstGeom prst="rect">
             <a:avLst/>
@@ -4953,46 +4737,11 @@
             <a:r>
               <a:rPr sz="700">
                 <a:solidFill>
-                  <a:srgbClr val="A0B4D2"/>
+                  <a:srgbClr val="8CA0C3"/>
                 </a:solidFill>
                 <a:latin typeface="Consolas"/>
               </a:rPr>
               <a:t>FKB Campus  ·  M02</a:t>
-            </a:r>
-          </a:p>
-        </p:txBody>
-      </p:sp>
-      <p:sp>
-        <p:nvSpPr>
-          <p:cNvPr id="10" name="TextBox 9"/>
-          <p:cNvSpPr txBox="1"/>
-          <p:nvPr/>
-        </p:nvSpPr>
-        <p:spPr>
-          <a:xfrm>
-            <a:off x="7176211" y="6583680"/>
-            <a:ext cx="4326940" cy="256032"/>
-          </a:xfrm>
-          <a:prstGeom prst="rect">
-            <a:avLst/>
-          </a:prstGeom>
-          <a:noFill/>
-        </p:spPr>
-        <p:txBody>
-          <a:bodyPr wrap="none">
-            <a:spAutoFit/>
-          </a:bodyPr>
-          <a:lstStyle/>
-          <a:p>
-            <a:pPr algn="r"/>
-            <a:r>
-              <a:rPr sz="700">
-                <a:solidFill>
-                  <a:srgbClr val="A0B4D2"/>
-                </a:solidFill>
-                <a:latin typeface="Consolas"/>
-              </a:rPr>
-              <a:t>Übersicht</a:t>
             </a:r>
           </a:p>
         </p:txBody>
@@ -5131,7 +4880,7 @@
                 </a:solidFill>
                 <a:latin typeface="Consolas"/>
               </a:rPr>
-              <a:t>M02  ·  INHALT</a:t>
+              <a:t>M02  ·  ARBEITSBLATT</a:t>
             </a:r>
           </a:p>
         </p:txBody>
@@ -5252,7 +5001,7 @@
                 </a:solidFill>
                 <a:latin typeface="Arial"/>
               </a:rPr>
-              <a:t>AB-1: Checkliste – Bilanzgespräch vorbereiten</a:t>
+              <a:t>Bilanzgespräch Schwäbische Metallbau bearbeiten</a:t>
             </a:r>
           </a:p>
         </p:txBody>
@@ -5265,8 +5014,8 @@
         </p:nvSpPr>
         <p:spPr>
           <a:xfrm>
-            <a:off x="685800" y="1417320"/>
-            <a:ext cx="10817352" cy="4892040"/>
+            <a:off x="685800" y="1554480"/>
+            <a:ext cx="10817352" cy="3840480"/>
           </a:xfrm>
           <a:prstGeom prst="rect">
             <a:avLst/>
@@ -5288,13 +5037,13 @@
               </a:spcAft>
             </a:pPr>
             <a:r>
-              <a:rPr sz="1300">
+              <a:rPr sz="1400">
                 <a:solidFill>
                   <a:srgbClr val="3D5466"/>
                 </a:solidFill>
                 <a:latin typeface="Arial"/>
               </a:rPr>
-              <a:t>▸  Vor dem Gespräch:</a:t>
+              <a:t>▸  Bereiten Sie das Bilanzgespräch mit der Schwäbischen Metallbau GmbH vor (AB-1).</a:t>
             </a:r>
           </a:p>
           <a:p>
@@ -5307,13 +5056,13 @@
               </a:spcAft>
             </a:pPr>
             <a:r>
-              <a:rPr sz="1300">
+              <a:rPr sz="1400">
                 <a:solidFill>
                   <a:srgbClr val="3D5466"/>
                 </a:solidFill>
                 <a:latin typeface="Arial"/>
               </a:rPr>
-              <a:t>▸  [ ] Jahresabschluss und Vorjahresvergleich ausgewertet</a:t>
+              <a:t>▸  Ordnen Sie die kritischen Kennzahlen den fünf Gesprächsphasen zu.</a:t>
             </a:r>
           </a:p>
           <a:p>
@@ -5326,191 +5075,98 @@
               </a:spcAft>
             </a:pPr>
             <a:r>
-              <a:rPr sz="1300">
+              <a:rPr sz="1400">
                 <a:solidFill>
                   <a:srgbClr val="3D5466"/>
                 </a:solidFill>
                 <a:latin typeface="Arial"/>
               </a:rPr>
-              <a:t>▸  [ ] 4+ Kennzahlen berechnet, Branchenvergleich notiert</a:t>
-            </a:r>
-          </a:p>
-          <a:p>
-            <a:pPr marL="190500" indent="-190500">
-              <a:spcBef>
-                <a:spcPts val="400"/>
-              </a:spcBef>
-              <a:spcAft>
-                <a:spcPts val="200"/>
-              </a:spcAft>
-            </a:pPr>
-            <a:r>
-              <a:rPr sz="1300">
-                <a:solidFill>
-                  <a:srgbClr val="3D5466"/>
+              <a:t>▸  Führen Sie das Gespräch im Rollenspiel und nutzen Sie den Beobachtungsbogen.</a:t>
+            </a:r>
+          </a:p>
+        </p:txBody>
+      </p:sp>
+      <p:sp>
+        <p:nvSpPr>
+          <p:cNvPr id="9" name="Rectangle 8"/>
+          <p:cNvSpPr/>
+          <p:nvPr/>
+        </p:nvSpPr>
+        <p:spPr>
+          <a:xfrm>
+            <a:off x="685800" y="5486400"/>
+            <a:ext cx="10817352" cy="640080"/>
+          </a:xfrm>
+          <a:prstGeom prst="rect">
+            <a:avLst/>
+          </a:prstGeom>
+          <a:solidFill>
+            <a:srgbClr val="1F2C56"/>
+          </a:solidFill>
+          <a:ln>
+            <a:noFill/>
+          </a:ln>
+        </p:spPr>
+        <p:style>
+          <a:lnRef idx="1">
+            <a:schemeClr val="accent1"/>
+          </a:lnRef>
+          <a:fillRef idx="3">
+            <a:schemeClr val="accent1"/>
+          </a:fillRef>
+          <a:effectRef idx="2">
+            <a:schemeClr val="accent1"/>
+          </a:effectRef>
+          <a:fontRef idx="minor">
+            <a:schemeClr val="lt1"/>
+          </a:fontRef>
+        </p:style>
+        <p:txBody>
+          <a:bodyPr rtlCol="0" anchor="ctr"/>
+          <a:lstStyle/>
+          <a:p>
+            <a:pPr algn="ctr"/>
+          </a:p>
+        </p:txBody>
+      </p:sp>
+      <p:sp>
+        <p:nvSpPr>
+          <p:cNvPr id="10" name="TextBox 9"/>
+          <p:cNvSpPr txBox="1"/>
+          <p:nvPr/>
+        </p:nvSpPr>
+        <p:spPr>
+          <a:xfrm>
+            <a:off x="868680" y="5596128"/>
+            <a:ext cx="10451592" cy="457200"/>
+          </a:xfrm>
+          <a:prstGeom prst="rect">
+            <a:avLst/>
+          </a:prstGeom>
+          <a:noFill/>
+        </p:spPr>
+        <p:txBody>
+          <a:bodyPr wrap="square">
+            <a:spAutoFit/>
+          </a:bodyPr>
+          <a:lstStyle/>
+          <a:p>
+            <a:pPr algn="l"/>
+            <a:r>
+              <a:rPr sz="1300" b="1" i="0">
+                <a:solidFill>
+                  <a:srgbClr val="FFFFFF"/>
                 </a:solidFill>
                 <a:latin typeface="Arial"/>
               </a:rPr>
-              <a:t>▸  [ ] 5 offene Fragen schriftlich vorbereitet</a:t>
-            </a:r>
-          </a:p>
-          <a:p>
-            <a:pPr marL="190500" indent="-190500">
-              <a:spcBef>
-                <a:spcPts val="400"/>
-              </a:spcBef>
-              <a:spcAft>
-                <a:spcPts val="200"/>
-              </a:spcAft>
-            </a:pPr>
-            <a:r>
-              <a:rPr sz="1300">
-                <a:solidFill>
-                  <a:srgbClr val="3D5466"/>
-                </a:solidFill>
-                <a:latin typeface="Arial"/>
-              </a:rPr>
-              <a:t>▸  [ ] Gesprächsziel definiert</a:t>
-            </a:r>
-          </a:p>
-          <a:p>
-            <a:pPr marL="190500" indent="-190500">
-              <a:spcBef>
-                <a:spcPts val="400"/>
-              </a:spcBef>
-              <a:spcAft>
-                <a:spcPts val="200"/>
-              </a:spcAft>
-            </a:pPr>
-            <a:r>
-              <a:rPr sz="1300">
-                <a:solidFill>
-                  <a:srgbClr val="3D5466"/>
-                </a:solidFill>
-                <a:latin typeface="Arial"/>
-              </a:rPr>
-              <a:t>▸  [ ] Kreditlinie / § 18 KWG-Unterlagen geprüft</a:t>
-            </a:r>
-          </a:p>
-          <a:p>
-            <a:pPr marL="190500" indent="-190500">
-              <a:spcBef>
-                <a:spcPts val="400"/>
-              </a:spcBef>
-              <a:spcAft>
-                <a:spcPts val="200"/>
-              </a:spcAft>
-            </a:pPr>
-            <a:r>
-              <a:rPr sz="1300">
-                <a:solidFill>
-                  <a:srgbClr val="3D5466"/>
-                </a:solidFill>
-                <a:latin typeface="Arial"/>
-              </a:rPr>
-              <a:t>▸  [ ] Verbundpartner-Bedarf gesichtet (R+V, Union Investment, DZ BANK)</a:t>
-            </a:r>
-          </a:p>
-          <a:p>
-            <a:pPr marL="190500" indent="-190500">
-              <a:spcBef>
-                <a:spcPts val="400"/>
-              </a:spcBef>
-              <a:spcAft>
-                <a:spcPts val="200"/>
-              </a:spcAft>
-            </a:pPr>
-            <a:r>
-              <a:rPr sz="1300">
-                <a:solidFill>
-                  <a:srgbClr val="3D5466"/>
-                </a:solidFill>
-                <a:latin typeface="Arial"/>
-              </a:rPr>
-              <a:t>▸  Im Gespräch:</a:t>
-            </a:r>
-          </a:p>
-          <a:p>
-            <a:pPr marL="190500" indent="-190500">
-              <a:spcBef>
-                <a:spcPts val="400"/>
-              </a:spcBef>
-              <a:spcAft>
-                <a:spcPts val="200"/>
-              </a:spcAft>
-            </a:pPr>
-            <a:r>
-              <a:rPr sz="1300">
-                <a:solidFill>
-                  <a:srgbClr val="3D5466"/>
-                </a:solidFill>
-                <a:latin typeface="Arial"/>
-              </a:rPr>
-              <a:t>▸  [ ] Positiver Einstieg, Agenda gesetzt</a:t>
-            </a:r>
-          </a:p>
-          <a:p>
-            <a:pPr marL="190500" indent="-190500">
-              <a:spcBef>
-                <a:spcPts val="400"/>
-              </a:spcBef>
-              <a:spcAft>
-                <a:spcPts val="200"/>
-              </a:spcAft>
-            </a:pPr>
-            <a:r>
-              <a:rPr sz="1300">
-                <a:solidFill>
-                  <a:srgbClr val="3D5466"/>
-                </a:solidFill>
-                <a:latin typeface="Arial"/>
-              </a:rPr>
-              <a:t>▸  [ ] Mindestens 40 % Redezeit für den Kunden</a:t>
-            </a:r>
-          </a:p>
-          <a:p>
-            <a:pPr marL="190500" indent="-190500">
-              <a:spcBef>
-                <a:spcPts val="400"/>
-              </a:spcBef>
-              <a:spcAft>
-                <a:spcPts val="200"/>
-              </a:spcAft>
-            </a:pPr>
-            <a:r>
-              <a:rPr sz="1300">
-                <a:solidFill>
-                  <a:srgbClr val="3D5466"/>
-                </a:solidFill>
-                <a:latin typeface="Arial"/>
-              </a:rPr>
-              <a:t>▸  [ ] Kritische Punkte mit offener Frage angesprochen</a:t>
-            </a:r>
-          </a:p>
-          <a:p>
-            <a:pPr marL="190500" indent="-190500">
-              <a:spcBef>
-                <a:spcPts val="400"/>
-              </a:spcBef>
-              <a:spcAft>
-                <a:spcPts val="200"/>
-              </a:spcAft>
-            </a:pPr>
-            <a:r>
-              <a:rPr sz="1300">
-                <a:solidFill>
-                  <a:srgbClr val="3D5466"/>
-                </a:solidFill>
-                <a:latin typeface="Arial"/>
-              </a:rPr>
-              <a:t>▸  [ ] Handlungsoptionen gemeinsam entwickelt</a:t>
-            </a:r>
-          </a:p>
-        </p:txBody>
-      </p:sp>
-      <p:sp>
-        <p:nvSpPr>
-          <p:cNvPr id="9" name="Rectangle 8"/>
+              <a:t>→  Bearbeitung im Teilnehmer-Workbook (Arbeitsblatt mit Ausfüllfeldern)</a:t>
+            </a:r>
+          </a:p>
+        </p:txBody>
+      </p:sp>
+      <p:sp>
+        <p:nvSpPr>
+          <p:cNvPr id="11" name="Rectangle 10"/>
           <p:cNvSpPr/>
           <p:nvPr/>
         </p:nvSpPr>
@@ -5553,7 +5209,7 @@
       </p:sp>
       <p:sp>
         <p:nvSpPr>
-          <p:cNvPr id="10" name="TextBox 9"/>
+          <p:cNvPr id="12" name="TextBox 11"/>
           <p:cNvSpPr txBox="1"/>
           <p:nvPr/>
         </p:nvSpPr>
@@ -5841,7 +5497,7 @@
                 </a:solidFill>
                 <a:latin typeface="Arial"/>
               </a:rPr>
-              <a:t>Reflexionsfragen</a:t>
+              <a:t>Prinzip dieses Moduls</a:t>
             </a:r>
           </a:p>
         </p:txBody>
@@ -5867,6 +5523,25 @@
             <a:spAutoFit/>
           </a:bodyPr>
           <a:lstStyle/>
+          <a:p>
+            <a:pPr marL="177800" indent="-177800">
+              <a:spcBef>
+                <a:spcPts val="600"/>
+              </a:spcBef>
+              <a:spcAft>
+                <a:spcPts val="200"/>
+              </a:spcAft>
+            </a:pPr>
+            <a:r>
+              <a:rPr sz="1200" i="1">
+                <a:solidFill>
+                  <a:srgbClr val="3D5466"/>
+                </a:solidFill>
+                <a:latin typeface="Arial"/>
+              </a:rPr>
+              <a:t>→  Bring kritische Zahlen ins Gespräch, ohne Abwehr auszulösen.</a:t>
+            </a:r>
+          </a:p>
           <a:p>
             <a:pPr marL="190500" indent="-190500">
               <a:spcBef>
@@ -5883,9 +5558,370 @@
                 </a:solidFill>
                 <a:latin typeface="Arial"/>
               </a:rPr>
-              <a:t>▸  An welcher Stelle im Rollenspiel haben Sie sich am wohlsten gefühlt? Warum?</a:t>
-            </a:r>
-          </a:p>
+              <a:t>▸  Wer im offenen Dialog fragt statt anklagt, erhält die Erklärung – und den nächsten Beratungsansatz.</a:t>
+            </a:r>
+          </a:p>
+        </p:txBody>
+      </p:sp>
+      <p:sp>
+        <p:nvSpPr>
+          <p:cNvPr id="9" name="Rectangle 8"/>
+          <p:cNvSpPr/>
+          <p:nvPr/>
+        </p:nvSpPr>
+        <p:spPr>
+          <a:xfrm>
+            <a:off x="0" y="6510528"/>
+            <a:ext cx="12188952" cy="347472"/>
+          </a:xfrm>
+          <a:prstGeom prst="rect">
+            <a:avLst/>
+          </a:prstGeom>
+          <a:solidFill>
+            <a:srgbClr val="0A1937"/>
+          </a:solidFill>
+          <a:ln>
+            <a:noFill/>
+          </a:ln>
+        </p:spPr>
+        <p:style>
+          <a:lnRef idx="1">
+            <a:schemeClr val="accent1"/>
+          </a:lnRef>
+          <a:fillRef idx="3">
+            <a:schemeClr val="accent1"/>
+          </a:fillRef>
+          <a:effectRef idx="2">
+            <a:schemeClr val="accent1"/>
+          </a:effectRef>
+          <a:fontRef idx="minor">
+            <a:schemeClr val="lt1"/>
+          </a:fontRef>
+        </p:style>
+        <p:txBody>
+          <a:bodyPr rtlCol="0" anchor="ctr"/>
+          <a:lstStyle/>
+          <a:p>
+            <a:pPr algn="ctr"/>
+          </a:p>
+        </p:txBody>
+      </p:sp>
+      <p:sp>
+        <p:nvSpPr>
+          <p:cNvPr id="10" name="TextBox 9"/>
+          <p:cNvSpPr txBox="1"/>
+          <p:nvPr/>
+        </p:nvSpPr>
+        <p:spPr>
+          <a:xfrm>
+            <a:off x="685800" y="6583680"/>
+            <a:ext cx="6490411" cy="256032"/>
+          </a:xfrm>
+          <a:prstGeom prst="rect">
+            <a:avLst/>
+          </a:prstGeom>
+          <a:noFill/>
+        </p:spPr>
+        <p:txBody>
+          <a:bodyPr wrap="none">
+            <a:spAutoFit/>
+          </a:bodyPr>
+          <a:lstStyle/>
+          <a:p>
+            <a:pPr algn="l"/>
+            <a:r>
+              <a:rPr sz="700">
+                <a:solidFill>
+                  <a:srgbClr val="A0B4D2"/>
+                </a:solidFill>
+                <a:latin typeface="Consolas"/>
+              </a:rPr>
+              <a:t>FKB Campus  ·  M02</a:t>
+            </a:r>
+          </a:p>
+        </p:txBody>
+      </p:sp>
+    </p:spTree>
+  </p:cSld>
+  <p:clrMapOvr>
+    <a:masterClrMapping/>
+  </p:clrMapOvr>
+</p:sld>
+</file>
+
+<file path=ppt/slides/slide13.xml><?xml version="1.0" encoding="utf-8"?>
+<p:sld xmlns:a="http://schemas.openxmlformats.org/drawingml/2006/main" xmlns:p="http://schemas.openxmlformats.org/presentationml/2006/main" xmlns:r="http://schemas.openxmlformats.org/officeDocument/2006/relationships">
+  <p:cSld>
+    <p:spTree>
+      <p:nvGrpSpPr>
+        <p:cNvPr id="1" name=""/>
+        <p:cNvGrpSpPr/>
+        <p:nvPr/>
+      </p:nvGrpSpPr>
+      <p:grpSpPr/>
+      <p:sp>
+        <p:nvSpPr>
+          <p:cNvPr id="2" name="Rectangle 1"/>
+          <p:cNvSpPr/>
+          <p:nvPr/>
+        </p:nvSpPr>
+        <p:spPr>
+          <a:xfrm>
+            <a:off x="0" y="0"/>
+            <a:ext cx="12188952" cy="6858000"/>
+          </a:xfrm>
+          <a:prstGeom prst="rect">
+            <a:avLst/>
+          </a:prstGeom>
+          <a:solidFill>
+            <a:srgbClr val="EDEDF3"/>
+          </a:solidFill>
+          <a:ln>
+            <a:noFill/>
+          </a:ln>
+        </p:spPr>
+        <p:style>
+          <a:lnRef idx="1">
+            <a:schemeClr val="accent1"/>
+          </a:lnRef>
+          <a:fillRef idx="3">
+            <a:schemeClr val="accent1"/>
+          </a:fillRef>
+          <a:effectRef idx="2">
+            <a:schemeClr val="accent1"/>
+          </a:effectRef>
+          <a:fontRef idx="minor">
+            <a:schemeClr val="lt1"/>
+          </a:fontRef>
+        </p:style>
+        <p:txBody>
+          <a:bodyPr rtlCol="0" anchor="ctr"/>
+          <a:lstStyle/>
+          <a:p>
+            <a:pPr algn="ctr"/>
+          </a:p>
+        </p:txBody>
+      </p:sp>
+      <p:sp>
+        <p:nvSpPr>
+          <p:cNvPr id="3" name="Rectangle 2"/>
+          <p:cNvSpPr/>
+          <p:nvPr/>
+        </p:nvSpPr>
+        <p:spPr>
+          <a:xfrm>
+            <a:off x="0" y="0"/>
+            <a:ext cx="12188952" cy="50292"/>
+          </a:xfrm>
+          <a:prstGeom prst="rect">
+            <a:avLst/>
+          </a:prstGeom>
+          <a:solidFill>
+            <a:srgbClr val="1F2C56"/>
+          </a:solidFill>
+          <a:ln>
+            <a:noFill/>
+          </a:ln>
+        </p:spPr>
+        <p:style>
+          <a:lnRef idx="1">
+            <a:schemeClr val="accent1"/>
+          </a:lnRef>
+          <a:fillRef idx="3">
+            <a:schemeClr val="accent1"/>
+          </a:fillRef>
+          <a:effectRef idx="2">
+            <a:schemeClr val="accent1"/>
+          </a:effectRef>
+          <a:fontRef idx="minor">
+            <a:schemeClr val="lt1"/>
+          </a:fontRef>
+        </p:style>
+        <p:txBody>
+          <a:bodyPr rtlCol="0" anchor="ctr"/>
+          <a:lstStyle/>
+          <a:p>
+            <a:pPr algn="ctr"/>
+          </a:p>
+        </p:txBody>
+      </p:sp>
+      <p:sp>
+        <p:nvSpPr>
+          <p:cNvPr id="4" name="TextBox 3"/>
+          <p:cNvSpPr txBox="1"/>
+          <p:nvPr/>
+        </p:nvSpPr>
+        <p:spPr>
+          <a:xfrm>
+            <a:off x="685800" y="109728"/>
+            <a:ext cx="10817352" cy="228600"/>
+          </a:xfrm>
+          <a:prstGeom prst="rect">
+            <a:avLst/>
+          </a:prstGeom>
+          <a:noFill/>
+        </p:spPr>
+        <p:txBody>
+          <a:bodyPr wrap="none">
+            <a:spAutoFit/>
+          </a:bodyPr>
+          <a:lstStyle/>
+          <a:p>
+            <a:pPr algn="l"/>
+            <a:r>
+              <a:rPr sz="750">
+                <a:solidFill>
+                  <a:srgbClr val="78808C"/>
+                </a:solidFill>
+                <a:latin typeface="Consolas"/>
+              </a:rPr>
+              <a:t>M02  ·  INHALT</a:t>
+            </a:r>
+          </a:p>
+        </p:txBody>
+      </p:sp>
+      <p:sp>
+        <p:nvSpPr>
+          <p:cNvPr id="5" name="Rectangle 4"/>
+          <p:cNvSpPr/>
+          <p:nvPr/>
+        </p:nvSpPr>
+        <p:spPr>
+          <a:xfrm>
+            <a:off x="0" y="1234440"/>
+            <a:ext cx="12188952" cy="12700"/>
+          </a:xfrm>
+          <a:prstGeom prst="rect">
+            <a:avLst/>
+          </a:prstGeom>
+          <a:solidFill>
+            <a:srgbClr val="D8DFE4"/>
+          </a:solidFill>
+          <a:ln>
+            <a:noFill/>
+          </a:ln>
+        </p:spPr>
+        <p:style>
+          <a:lnRef idx="1">
+            <a:schemeClr val="accent1"/>
+          </a:lnRef>
+          <a:fillRef idx="3">
+            <a:schemeClr val="accent1"/>
+          </a:fillRef>
+          <a:effectRef idx="2">
+            <a:schemeClr val="accent1"/>
+          </a:effectRef>
+          <a:fontRef idx="minor">
+            <a:schemeClr val="lt1"/>
+          </a:fontRef>
+        </p:style>
+        <p:txBody>
+          <a:bodyPr rtlCol="0" anchor="ctr"/>
+          <a:lstStyle/>
+          <a:p>
+            <a:pPr algn="ctr"/>
+          </a:p>
+        </p:txBody>
+      </p:sp>
+      <p:sp>
+        <p:nvSpPr>
+          <p:cNvPr id="6" name="Rectangle 5"/>
+          <p:cNvSpPr/>
+          <p:nvPr/>
+        </p:nvSpPr>
+        <p:spPr>
+          <a:xfrm>
+            <a:off x="685800" y="502920"/>
+            <a:ext cx="36576" cy="658368"/>
+          </a:xfrm>
+          <a:prstGeom prst="rect">
+            <a:avLst/>
+          </a:prstGeom>
+          <a:solidFill>
+            <a:srgbClr val="D9C089"/>
+          </a:solidFill>
+          <a:ln>
+            <a:noFill/>
+          </a:ln>
+        </p:spPr>
+        <p:style>
+          <a:lnRef idx="1">
+            <a:schemeClr val="accent1"/>
+          </a:lnRef>
+          <a:fillRef idx="3">
+            <a:schemeClr val="accent1"/>
+          </a:fillRef>
+          <a:effectRef idx="2">
+            <a:schemeClr val="accent1"/>
+          </a:effectRef>
+          <a:fontRef idx="minor">
+            <a:schemeClr val="lt1"/>
+          </a:fontRef>
+        </p:style>
+        <p:txBody>
+          <a:bodyPr rtlCol="0" anchor="ctr"/>
+          <a:lstStyle/>
+          <a:p>
+            <a:pPr algn="ctr"/>
+          </a:p>
+        </p:txBody>
+      </p:sp>
+      <p:sp>
+        <p:nvSpPr>
+          <p:cNvPr id="7" name="TextBox 6"/>
+          <p:cNvSpPr txBox="1"/>
+          <p:nvPr/>
+        </p:nvSpPr>
+        <p:spPr>
+          <a:xfrm>
+            <a:off x="813816" y="502920"/>
+            <a:ext cx="10634472" cy="685800"/>
+          </a:xfrm>
+          <a:prstGeom prst="rect">
+            <a:avLst/>
+          </a:prstGeom>
+          <a:noFill/>
+        </p:spPr>
+        <p:txBody>
+          <a:bodyPr wrap="square">
+            <a:spAutoFit/>
+          </a:bodyPr>
+          <a:lstStyle/>
+          <a:p>
+            <a:pPr algn="l"/>
+            <a:r>
+              <a:rPr sz="2400" b="1" i="0">
+                <a:solidFill>
+                  <a:srgbClr val="1F2C56"/>
+                </a:solidFill>
+                <a:latin typeface="Arial"/>
+              </a:rPr>
+              <a:t>Reflexion und Selbstcheck</a:t>
+            </a:r>
+          </a:p>
+        </p:txBody>
+      </p:sp>
+      <p:sp>
+        <p:nvSpPr>
+          <p:cNvPr id="8" name="TextBox 7"/>
+          <p:cNvSpPr txBox="1"/>
+          <p:nvPr/>
+        </p:nvSpPr>
+        <p:spPr>
+          <a:xfrm>
+            <a:off x="685800" y="1417320"/>
+            <a:ext cx="10817352" cy="4892040"/>
+          </a:xfrm>
+          <a:prstGeom prst="rect">
+            <a:avLst/>
+          </a:prstGeom>
+          <a:noFill/>
+        </p:spPr>
+        <p:txBody>
+          <a:bodyPr wrap="square" anchor="ctr">
+            <a:spAutoFit/>
+          </a:bodyPr>
+          <a:lstStyle/>
           <a:p>
             <a:pPr marL="190500" indent="-190500">
               <a:spcBef>
@@ -5902,7 +5938,7 @@
                 </a:solidFill>
                 <a:latin typeface="Arial"/>
               </a:rPr>
-              <a:t>▸  Wo haben Sie gemerkt, dass Ihnen eine Technik noch nicht in Fleisch und Blut übergegangen ist?</a:t>
+              <a:t>▸  Bei welcher kritischen Kennzahl löst Ihre Formulierung bisher am ehesten Abwehr aus?</a:t>
             </a:r>
           </a:p>
           <a:p>
@@ -5921,7 +5957,7 @@
                 </a:solidFill>
                 <a:latin typeface="Arial"/>
               </a:rPr>
-              <a:t>▸  Welchen konkreten Kunden würden Sie gerne beim nächsten Gespräch mit den neuen Techniken ansprechen?</a:t>
+              <a:t>▸  Welche der fünf Phasen überspringen Sie im Alltag am häufigsten?</a:t>
             </a:r>
           </a:p>
           <a:p>
@@ -5940,7 +5976,7 @@
                 </a:solidFill>
                 <a:latin typeface="Arial"/>
               </a:rPr>
-              <a:t>▸  Was nehmen Sie sich vor, beim nächsten echten Bilanzgespräch anders zu machen?</a:t>
+              <a:t>▸  Wie formulieren Sie eine schlechte Kennzahl als Frage statt als Vorwurf?</a:t>
             </a:r>
           </a:p>
         </p:txBody>
@@ -7782,7 +7818,7 @@
                 </a:solidFill>
                 <a:latin typeface="Arial"/>
               </a:rPr>
-              <a:t>Theorie-Input: Vom Zahlenleser zum Gesprächsführer</a:t>
+              <a:t>Kritische Zahlen ins Gespräch bringen – ohne Abwehr</a:t>
             </a:r>
           </a:p>
         </p:txBody>
@@ -7804,27 +7840,27 @@
           <a:noFill/>
         </p:spPr>
         <p:txBody>
-          <a:bodyPr wrap="square">
+          <a:bodyPr wrap="square" anchor="ctr">
             <a:spAutoFit/>
           </a:bodyPr>
           <a:lstStyle/>
           <a:p>
-            <a:pPr>
+            <a:pPr marL="177800" indent="-177800">
               <a:spcBef>
-                <a:spcPts val="1000"/>
+                <a:spcPts val="600"/>
               </a:spcBef>
               <a:spcAft>
                 <a:spcPts val="200"/>
               </a:spcAft>
             </a:pPr>
             <a:r>
-              <a:rPr sz="800" b="1">
-                <a:solidFill>
-                  <a:srgbClr val="78808C"/>
-                </a:solidFill>
-                <a:latin typeface="Consolas"/>
-              </a:rPr>
-              <a:t>DIE GRENZEN DER REINEN KENNZAHLENANALYSE</a:t>
+              <a:rPr sz="1200" i="1">
+                <a:solidFill>
+                  <a:srgbClr val="3D5466"/>
+                </a:solidFill>
+                <a:latin typeface="Arial"/>
+              </a:rPr>
+              <a:t>→  Bring kritische Zahlen ins Gespräch, ohne Abwehr auszulösen.</a:t>
             </a:r>
           </a:p>
           <a:p>
@@ -7843,26 +7879,7 @@
                 </a:solidFill>
                 <a:latin typeface="Arial"/>
               </a:rPr>
-              <a:t>▸  Der Jahresabschluss beantwortet die Frage: „Wie ist die finanzielle Situation?" . Diese Analyse ist die Grundlage des Kreditgeschäfts – und gleichzeitig nur die Hälfte der Geschichte.</a:t>
-            </a:r>
-          </a:p>
-          <a:p>
-            <a:pPr>
-              <a:spcBef>
-                <a:spcPts val="1000"/>
-              </a:spcBef>
-              <a:spcAft>
-                <a:spcPts val="200"/>
-              </a:spcAft>
-            </a:pPr>
-            <a:r>
-              <a:rPr sz="800" b="1">
-                <a:solidFill>
-                  <a:srgbClr val="78808C"/>
-                </a:solidFill>
-                <a:latin typeface="Consolas"/>
-              </a:rPr>
-              <a:t>KOMMUNIKATION AUF AUGENHÖHE: INHALTS- VS. BEZIEHUNGSEBENE</a:t>
+              <a:t>▸  Wer im offenen Dialog fragt statt anklagt, erhält die Erklärung – und den nächsten Beratungsansatz.</a:t>
             </a:r>
           </a:p>
           <a:p>
@@ -7881,159 +7898,7 @@
                 </a:solidFill>
                 <a:latin typeface="Arial"/>
               </a:rPr>
-              <a:t>▸  Das Muster: Beobachtung + offene Frage statt Beobachtung + Bewertung.</a:t>
-            </a:r>
-          </a:p>
-          <a:p>
-            <a:pPr>
-              <a:spcBef>
-                <a:spcPts val="1000"/>
-              </a:spcBef>
-              <a:spcAft>
-                <a:spcPts val="200"/>
-              </a:spcAft>
-            </a:pPr>
-            <a:r>
-              <a:rPr sz="800" b="1">
-                <a:solidFill>
-                  <a:srgbClr val="78808C"/>
-                </a:solidFill>
-                <a:latin typeface="Consolas"/>
-              </a:rPr>
-              <a:t>DER 5-PHASEN-RAHMEN FÜR DAS BILANZGESPRÄCH</a:t>
-            </a:r>
-          </a:p>
-          <a:p>
-            <a:pPr marL="190500" indent="-190500">
-              <a:spcBef>
-                <a:spcPts val="400"/>
-              </a:spcBef>
-              <a:spcAft>
-                <a:spcPts val="200"/>
-              </a:spcAft>
-            </a:pPr>
-            <a:r>
-              <a:rPr sz="1300">
-                <a:solidFill>
-                  <a:srgbClr val="3D5466"/>
-                </a:solidFill>
-                <a:latin typeface="Arial"/>
-              </a:rPr>
-              <a:t>▸  Phase 1 – Vorbereitung (30–45 Min. vor dem Termin)</a:t>
-            </a:r>
-          </a:p>
-          <a:p>
-            <a:pPr marL="190500" indent="-190500">
-              <a:spcBef>
-                <a:spcPts val="400"/>
-              </a:spcBef>
-              <a:spcAft>
-                <a:spcPts val="200"/>
-              </a:spcAft>
-            </a:pPr>
-            <a:r>
-              <a:rPr sz="1300">
-                <a:solidFill>
-                  <a:srgbClr val="3D5466"/>
-                </a:solidFill>
-                <a:latin typeface="Arial"/>
-              </a:rPr>
-              <a:t>▸  Mindestens 4 Kennzahlen berechnen (EK-Quote, Liquidität, Verschuldungsgrad, EBIT-Marge)</a:t>
-            </a:r>
-          </a:p>
-          <a:p>
-            <a:pPr marL="190500" indent="-190500">
-              <a:spcBef>
-                <a:spcPts val="400"/>
-              </a:spcBef>
-              <a:spcAft>
-                <a:spcPts val="200"/>
-              </a:spcAft>
-            </a:pPr>
-            <a:r>
-              <a:rPr sz="1300">
-                <a:solidFill>
-                  <a:srgbClr val="3D5466"/>
-                </a:solidFill>
-                <a:latin typeface="Arial"/>
-              </a:rPr>
-              <a:t>▸  Zeitreihe: Vergleich zu mindestens 2 Vorjahren</a:t>
-            </a:r>
-          </a:p>
-          <a:p>
-            <a:pPr marL="190500" indent="-190500">
-              <a:spcBef>
-                <a:spcPts val="400"/>
-              </a:spcBef>
-              <a:spcAft>
-                <a:spcPts val="200"/>
-              </a:spcAft>
-            </a:pPr>
-            <a:r>
-              <a:rPr sz="1300">
-                <a:solidFill>
-                  <a:srgbClr val="3D5466"/>
-                </a:solidFill>
-                <a:latin typeface="Arial"/>
-              </a:rPr>
-              <a:t>▸  Branchenwert recherchieren: In agree (Firmenkundenanalyse) stehen aktuelle Branchenbenchmarks aus der Creditreform/Bisnode-Lizenz direkt im Analysebogen – diese Werte für das Gespräch bevorzugen. Alternativ: Bundesbank Unternehmensabschlussstatistik (kostenfrei, aber teils 2 Jahre zeitverzögert)</a:t>
-            </a:r>
-          </a:p>
-          <a:p>
-            <a:pPr marL="190500" indent="-190500">
-              <a:spcBef>
-                <a:spcPts val="400"/>
-              </a:spcBef>
-              <a:spcAft>
-                <a:spcPts val="200"/>
-              </a:spcAft>
-            </a:pPr>
-            <a:r>
-              <a:rPr sz="1300">
-                <a:solidFill>
-                  <a:srgbClr val="3D5466"/>
-                </a:solidFill>
-                <a:latin typeface="Arial"/>
-              </a:rPr>
-              <a:t>▸  3 Schlüsselbotschaften + 5 offene Fragen schriftlich vorbereiten</a:t>
-            </a:r>
-          </a:p>
-          <a:p>
-            <a:pPr marL="190500" indent="-190500">
-              <a:spcBef>
-                <a:spcPts val="400"/>
-              </a:spcBef>
-              <a:spcAft>
-                <a:spcPts val="200"/>
-              </a:spcAft>
-            </a:pPr>
-            <a:r>
-              <a:rPr sz="1300">
-                <a:solidFill>
-                  <a:srgbClr val="3D5466"/>
-                </a:solidFill>
-                <a:latin typeface="Arial"/>
-              </a:rPr>
-              <a:t>▸  Phase 2 – Eröffnung (ca. 10 Min.)</a:t>
-            </a:r>
-          </a:p>
-          <a:p>
-            <a:pPr marL="190500" indent="-190500">
-              <a:spcBef>
-                <a:spcPts val="400"/>
-              </a:spcBef>
-              <a:spcAft>
-                <a:spcPts val="200"/>
-              </a:spcAft>
-            </a:pPr>
-            <a:r>
-              <a:rPr sz="1300">
-                <a:solidFill>
-                  <a:srgbClr val="3D5466"/>
-                </a:solidFill>
-                <a:latin typeface="Arial"/>
-              </a:rPr>
-              <a:t>▸  Kontext und Ziel setzen: „Heute möchte ich mit Ihnen Ihren Jahresabschluss durchgehen und verstehen, wie sich Ihre Lage entwickelt hat."</a:t>
+              <a:t>▸  Vom Zahlenleser zum Gesprächsführer: die Analyse ist die halbe Miete, das Gespräch die andere.</a:t>
             </a:r>
           </a:p>
         </p:txBody>
@@ -8149,7 +8014,7 @@
             <a:avLst/>
           </a:prstGeom>
           <a:solidFill>
-            <a:srgbClr val="FFFFFF"/>
+            <a:srgbClr val="EDEDF3"/>
           </a:solidFill>
           <a:ln>
             <a:noFill/>
@@ -8250,43 +8115,51 @@
                 </a:solidFill>
                 <a:latin typeface="Consolas"/>
               </a:rPr>
-              <a:t>M02  ·  SCHAUBILD</a:t>
-            </a:r>
-          </a:p>
-        </p:txBody>
-      </p:sp>
-      <p:sp>
-        <p:nvSpPr>
-          <p:cNvPr id="5" name="TextBox 4"/>
-          <p:cNvSpPr txBox="1"/>
-          <p:nvPr/>
-        </p:nvSpPr>
-        <p:spPr>
-          <a:xfrm>
-            <a:off x="685800" y="502920"/>
-            <a:ext cx="10817352" cy="594360"/>
-          </a:xfrm>
-          <a:prstGeom prst="rect">
-            <a:avLst/>
-          </a:prstGeom>
-          <a:noFill/>
-        </p:spPr>
-        <p:txBody>
-          <a:bodyPr wrap="square">
-            <a:spAutoFit/>
-          </a:bodyPr>
-          <a:lstStyle/>
-          <a:p>
-            <a:pPr algn="l"/>
-            <a:r>
-              <a:rPr sz="2000" b="1" i="0">
-                <a:solidFill>
-                  <a:srgbClr val="1F2C56"/>
-                </a:solidFill>
-                <a:latin typeface="Arial"/>
-              </a:rPr>
-              <a:t>Vier-Ohren-Modell nach Schulz von Thun</a:t>
-            </a:r>
+              <a:t>M02  ·  INHALT</a:t>
+            </a:r>
+          </a:p>
+        </p:txBody>
+      </p:sp>
+      <p:sp>
+        <p:nvSpPr>
+          <p:cNvPr id="5" name="Rectangle 4"/>
+          <p:cNvSpPr/>
+          <p:nvPr/>
+        </p:nvSpPr>
+        <p:spPr>
+          <a:xfrm>
+            <a:off x="0" y="1234440"/>
+            <a:ext cx="12188952" cy="12700"/>
+          </a:xfrm>
+          <a:prstGeom prst="rect">
+            <a:avLst/>
+          </a:prstGeom>
+          <a:solidFill>
+            <a:srgbClr val="D8DFE4"/>
+          </a:solidFill>
+          <a:ln>
+            <a:noFill/>
+          </a:ln>
+        </p:spPr>
+        <p:style>
+          <a:lnRef idx="1">
+            <a:schemeClr val="accent1"/>
+          </a:lnRef>
+          <a:fillRef idx="3">
+            <a:schemeClr val="accent1"/>
+          </a:fillRef>
+          <a:effectRef idx="2">
+            <a:schemeClr val="accent1"/>
+          </a:effectRef>
+          <a:fontRef idx="minor">
+            <a:schemeClr val="lt1"/>
+          </a:fontRef>
+        </p:style>
+        <p:txBody>
+          <a:bodyPr rtlCol="0" anchor="ctr"/>
+          <a:lstStyle/>
+          <a:p>
+            <a:pPr algn="ctr"/>
           </a:p>
         </p:txBody>
       </p:sp>
@@ -8298,8 +8171,8 @@
         </p:nvSpPr>
         <p:spPr>
           <a:xfrm>
-            <a:off x="685800" y="1143000"/>
-            <a:ext cx="10817352" cy="25400"/>
+            <a:off x="685800" y="502920"/>
+            <a:ext cx="36576" cy="658368"/>
           </a:xfrm>
           <a:prstGeom prst="rect">
             <a:avLst/>
@@ -8333,33 +8206,124 @@
           </a:p>
         </p:txBody>
       </p:sp>
-      <p:pic>
-        <p:nvPicPr>
-          <p:cNvPr id="7" name="Picture 6" descr="image.png"/>
-          <p:cNvPicPr>
-            <a:picLocks noChangeAspect="1"/>
-          </p:cNvPicPr>
-          <p:nvPr/>
-        </p:nvPicPr>
-        <p:blipFill>
-          <a:blip r:embed="rId2"/>
-          <a:stretch>
-            <a:fillRect/>
-          </a:stretch>
-        </p:blipFill>
-        <p:spPr>
-          <a:xfrm>
-            <a:off x="2554863" y="1325880"/>
-            <a:ext cx="7079225" cy="4937760"/>
-          </a:xfrm>
-          <a:prstGeom prst="rect">
-            <a:avLst/>
-          </a:prstGeom>
-        </p:spPr>
-      </p:pic>
-      <p:sp>
-        <p:nvSpPr>
-          <p:cNvPr id="8" name="Rectangle 7"/>
+      <p:sp>
+        <p:nvSpPr>
+          <p:cNvPr id="7" name="TextBox 6"/>
+          <p:cNvSpPr txBox="1"/>
+          <p:nvPr/>
+        </p:nvSpPr>
+        <p:spPr>
+          <a:xfrm>
+            <a:off x="813816" y="502920"/>
+            <a:ext cx="10634472" cy="685800"/>
+          </a:xfrm>
+          <a:prstGeom prst="rect">
+            <a:avLst/>
+          </a:prstGeom>
+          <a:noFill/>
+        </p:spPr>
+        <p:txBody>
+          <a:bodyPr wrap="square">
+            <a:spAutoFit/>
+          </a:bodyPr>
+          <a:lstStyle/>
+          <a:p>
+            <a:pPr algn="l"/>
+            <a:r>
+              <a:rPr sz="2400" b="1" i="0">
+                <a:solidFill>
+                  <a:srgbClr val="1F2C56"/>
+                </a:solidFill>
+                <a:latin typeface="Arial"/>
+              </a:rPr>
+              <a:t>Reine Kennzahlenanalyse stößt an ihre Grenzen</a:t>
+            </a:r>
+          </a:p>
+        </p:txBody>
+      </p:sp>
+      <p:sp>
+        <p:nvSpPr>
+          <p:cNvPr id="8" name="TextBox 7"/>
+          <p:cNvSpPr txBox="1"/>
+          <p:nvPr/>
+        </p:nvSpPr>
+        <p:spPr>
+          <a:xfrm>
+            <a:off x="685800" y="1417320"/>
+            <a:ext cx="10817352" cy="4892040"/>
+          </a:xfrm>
+          <a:prstGeom prst="rect">
+            <a:avLst/>
+          </a:prstGeom>
+          <a:noFill/>
+        </p:spPr>
+        <p:txBody>
+          <a:bodyPr wrap="square" anchor="ctr">
+            <a:spAutoFit/>
+          </a:bodyPr>
+          <a:lstStyle/>
+          <a:p>
+            <a:pPr marL="177800" indent="-177800">
+              <a:spcBef>
+                <a:spcPts val="600"/>
+              </a:spcBef>
+              <a:spcAft>
+                <a:spcPts val="200"/>
+              </a:spcAft>
+            </a:pPr>
+            <a:r>
+              <a:rPr sz="1200" i="1">
+                <a:solidFill>
+                  <a:srgbClr val="3D5466"/>
+                </a:solidFill>
+                <a:latin typeface="Arial"/>
+              </a:rPr>
+              <a:t>→  Eine Kennzahl erklärt sich nicht selbst – erst das Gespräch macht aus der Zahl eine Geschichte.</a:t>
+            </a:r>
+          </a:p>
+          <a:p>
+            <a:pPr marL="190500" indent="-190500">
+              <a:spcBef>
+                <a:spcPts val="400"/>
+              </a:spcBef>
+              <a:spcAft>
+                <a:spcPts val="200"/>
+              </a:spcAft>
+            </a:pPr>
+            <a:r>
+              <a:rPr sz="1300">
+                <a:solidFill>
+                  <a:srgbClr val="3D5466"/>
+                </a:solidFill>
+                <a:latin typeface="Arial"/>
+              </a:rPr>
+              <a:t>▸  Kommunikation auf Augenhöhe: die Beziehungsebene trägt die Sachebene.</a:t>
+            </a:r>
+          </a:p>
+          <a:p>
+            <a:pPr marL="190500" indent="-190500">
+              <a:spcBef>
+                <a:spcPts val="400"/>
+              </a:spcBef>
+              <a:spcAft>
+                <a:spcPts val="200"/>
+              </a:spcAft>
+            </a:pPr>
+            <a:r>
+              <a:rPr sz="1300">
+                <a:solidFill>
+                  <a:srgbClr val="3D5466"/>
+                </a:solidFill>
+                <a:latin typeface="Arial"/>
+              </a:rPr>
+              <a:t>▸  Das Vier-Ohren-Modell hilft, Einwände als Beziehungs- oder Appellbotschaft zu verstehen.</a:t>
+            </a:r>
+          </a:p>
+        </p:txBody>
+      </p:sp>
+      <p:sp>
+        <p:nvSpPr>
+          <p:cNvPr id="9" name="Rectangle 8"/>
           <p:cNvSpPr/>
           <p:nvPr/>
         </p:nvSpPr>
@@ -8402,7 +8366,7 @@
       </p:sp>
       <p:sp>
         <p:nvSpPr>
-          <p:cNvPr id="9" name="TextBox 8"/>
+          <p:cNvPr id="10" name="TextBox 9"/>
           <p:cNvSpPr txBox="1"/>
           <p:nvPr/>
         </p:nvSpPr>
@@ -8431,41 +8395,6 @@
                 <a:latin typeface="Consolas"/>
               </a:rPr>
               <a:t>FKB Campus  ·  M02</a:t>
-            </a:r>
-          </a:p>
-        </p:txBody>
-      </p:sp>
-      <p:sp>
-        <p:nvSpPr>
-          <p:cNvPr id="10" name="TextBox 9"/>
-          <p:cNvSpPr txBox="1"/>
-          <p:nvPr/>
-        </p:nvSpPr>
-        <p:spPr>
-          <a:xfrm>
-            <a:off x="7176211" y="6583680"/>
-            <a:ext cx="4326940" cy="256032"/>
-          </a:xfrm>
-          <a:prstGeom prst="rect">
-            <a:avLst/>
-          </a:prstGeom>
-          <a:noFill/>
-        </p:spPr>
-        <p:txBody>
-          <a:bodyPr wrap="none">
-            <a:spAutoFit/>
-          </a:bodyPr>
-          <a:lstStyle/>
-          <a:p>
-            <a:pPr algn="r"/>
-            <a:r>
-              <a:rPr sz="700">
-                <a:solidFill>
-                  <a:srgbClr val="A0B4D2"/>
-                </a:solidFill>
-                <a:latin typeface="Consolas"/>
-              </a:rPr>
-              <a:t>Schaubild</a:t>
             </a:r>
           </a:p>
         </p:txBody>
@@ -8639,7 +8568,7 @@
                 </a:solidFill>
                 <a:latin typeface="Arial"/>
               </a:rPr>
-              <a:t>5-Phasen-Rahmen für das strukturierte Bilanzgespräch</a:t>
+              <a:t>Das Vier-Ohren-Modell nach Schulz von Thun</a:t>
             </a:r>
           </a:p>
         </p:txBody>
@@ -8703,8 +8632,8 @@
         </p:blipFill>
         <p:spPr>
           <a:xfrm>
-            <a:off x="1670951" y="1325880"/>
-            <a:ext cx="8847050" cy="4937760"/>
+            <a:off x="2554863" y="1325880"/>
+            <a:ext cx="7079225" cy="4937760"/>
           </a:xfrm>
           <a:prstGeom prst="rect">
             <a:avLst/>
@@ -9079,7 +9008,7 @@
                 </a:solidFill>
                 <a:latin typeface="Arial"/>
               </a:rPr>
-              <a:t>Praxiscase: Schwäbische Metallbau GmbH</a:t>
+              <a:t>Der 5-Phasen-Rahmen für das Bilanzgespräch</a:t>
             </a:r>
           </a:p>
         </p:txBody>
@@ -9101,10 +9030,29 @@
           <a:noFill/>
         </p:spPr>
         <p:txBody>
-          <a:bodyPr wrap="square">
+          <a:bodyPr wrap="square" anchor="ctr">
             <a:spAutoFit/>
           </a:bodyPr>
           <a:lstStyle/>
+          <a:p>
+            <a:pPr marL="177800" indent="-177800">
+              <a:spcBef>
+                <a:spcPts val="600"/>
+              </a:spcBef>
+              <a:spcAft>
+                <a:spcPts val="200"/>
+              </a:spcAft>
+            </a:pPr>
+            <a:r>
+              <a:rPr sz="1200" i="1">
+                <a:solidFill>
+                  <a:srgbClr val="3D5466"/>
+                </a:solidFill>
+                <a:latin typeface="Arial"/>
+              </a:rPr>
+              <a:t>→  Ein strukturiertes Bilanzgespräch folgt fünf Phasen – vom Rahmen über die Analyse bis zum vereinbarten nächsten Schritt.</a:t>
+            </a:r>
+          </a:p>
           <a:p>
             <a:pPr marL="190500" indent="-190500">
               <a:spcBef>
@@ -9121,7 +9069,7 @@
                 </a:solidFill>
                 <a:latin typeface="Arial"/>
               </a:rPr>
-              <a:t>▸  Finanzdaten (fiktiv):</a:t>
+              <a:t>▸  Eröffnung, gemeinsame Standortbestimmung, kritische Punkte, Lösungsraum, Abschluss.</a:t>
             </a:r>
           </a:p>
           <a:p>
@@ -9140,121 +9088,7 @@
                 </a:solidFill>
                 <a:latin typeface="Arial"/>
               </a:rPr>
-              <a:t>▸  Quelle: Deutsche Bundesbank, Unternehmensabschlussstatistik (laufend)</a:t>
-            </a:r>
-          </a:p>
-          <a:p>
-            <a:pPr marL="190500" indent="-190500">
-              <a:spcBef>
-                <a:spcPts val="400"/>
-              </a:spcBef>
-              <a:spcAft>
-                <a:spcPts val="200"/>
-              </a:spcAft>
-            </a:pPr>
-            <a:r>
-              <a:rPr sz="1300">
-                <a:solidFill>
-                  <a:srgbClr val="3D5466"/>
-                </a:solidFill>
-                <a:latin typeface="Arial"/>
-              </a:rPr>
-              <a:t>▸  Rollenbeschreibungen:</a:t>
-            </a:r>
-          </a:p>
-          <a:p>
-            <a:pPr marL="190500" indent="-190500">
-              <a:spcBef>
-                <a:spcPts val="400"/>
-              </a:spcBef>
-              <a:spcAft>
-                <a:spcPts val="200"/>
-              </a:spcAft>
-            </a:pPr>
-            <a:r>
-              <a:rPr sz="1300">
-                <a:solidFill>
-                  <a:srgbClr val="3D5466"/>
-                </a:solidFill>
-                <a:latin typeface="Arial"/>
-              </a:rPr>
-              <a:t>▸  Rolle A – Berater (erhält nur diese Informationen — keine Hintergrundinfos)</a:t>
-            </a:r>
-          </a:p>
-          <a:p>
-            <a:pPr marL="190500" indent="-190500">
-              <a:spcBef>
-                <a:spcPts val="400"/>
-              </a:spcBef>
-              <a:spcAft>
-                <a:spcPts val="200"/>
-              </a:spcAft>
-            </a:pPr>
-            <a:r>
-              <a:rPr sz="1300">
-                <a:solidFill>
-                  <a:srgbClr val="3D5466"/>
-                </a:solidFill>
-                <a:latin typeface="Arial"/>
-              </a:rPr>
-              <a:t>▸  Rolle B – GF Martin Klemm (+ Trainer-Karte mit Hintergrundinfos)</a:t>
-            </a:r>
-          </a:p>
-          <a:p>
-            <a:pPr marL="190500" indent="-190500">
-              <a:spcBef>
-                <a:spcPts val="400"/>
-              </a:spcBef>
-              <a:spcAft>
-                <a:spcPts val="200"/>
-              </a:spcAft>
-            </a:pPr>
-            <a:r>
-              <a:rPr sz="1300">
-                <a:solidFill>
-                  <a:srgbClr val="3D5466"/>
-                </a:solidFill>
-                <a:latin typeface="Arial"/>
-              </a:rPr>
-              <a:t>▸  Rolle C – Beobachter: Beobachtungsbogen nutzen (s. u.), konkrete Gesprächssequenzen festhalten, nicht nur Urteile.</a:t>
-            </a:r>
-          </a:p>
-          <a:p>
-            <a:pPr>
-              <a:spcBef>
-                <a:spcPts val="1000"/>
-              </a:spcBef>
-              <a:spcAft>
-                <a:spcPts val="200"/>
-              </a:spcAft>
-            </a:pPr>
-            <a:r>
-              <a:rPr sz="800" b="1">
-                <a:solidFill>
-                  <a:srgbClr val="78808C"/>
-                </a:solidFill>
-                <a:latin typeface="Consolas"/>
-              </a:rPr>
-              <a:t>BEOBACHTUNGSBOGEN ROLLENSPIEL</a:t>
-            </a:r>
-          </a:p>
-          <a:p>
-            <a:pPr marL="190500" indent="-190500">
-              <a:spcBef>
-                <a:spcPts val="400"/>
-              </a:spcBef>
-              <a:spcAft>
-                <a:spcPts val="200"/>
-              </a:spcAft>
-            </a:pPr>
-            <a:r>
-              <a:rPr sz="1300">
-                <a:solidFill>
-                  <a:srgbClr val="3D5466"/>
-                </a:solidFill>
-                <a:latin typeface="Arial"/>
-              </a:rPr>
-              <a:t>▸  Skala: 1 = gar nicht sichtbar · 3 = ansatzweise · 5 = sehr gut</a:t>
+              <a:t>▸  Kritische Zahlen kommen in Phase 3 – eingebettet in Verständnis, nicht am Anfang.</a:t>
             </a:r>
           </a:p>
         </p:txBody>
@@ -9471,7 +9305,7 @@
                 </a:solidFill>
                 <a:latin typeface="Consolas"/>
               </a:rPr>
-              <a:t>M02  ·  ÜBERSICHT</a:t>
+              <a:t>M02  ·  SCHAUBILD</a:t>
             </a:r>
           </a:p>
         </p:txBody>
@@ -9506,7 +9340,7 @@
                 </a:solidFill>
                 <a:latin typeface="Arial"/>
               </a:rPr>
-              <a:t>Praxiscase: Schwäbische Metallbau GmbH</a:t>
+              <a:t>Der 5-Phasen-Rahmen für das strukturierte Bilanzgespräch</a:t>
             </a:r>
           </a:p>
         </p:txBody>
@@ -9554,494 +9388,30 @@
           </a:p>
         </p:txBody>
       </p:sp>
-      <p:graphicFrame>
-        <p:nvGraphicFramePr>
-          <p:cNvPr id="7" name="Table 6"/>
-          <p:cNvGraphicFramePr>
-            <a:graphicFrameLocks noGrp="1"/>
-          </p:cNvGraphicFramePr>
-          <p:nvPr/>
-        </p:nvGraphicFramePr>
-        <p:xfrm>
-          <a:off x="685800" y="1417320"/>
-          <a:ext cx="10817352" cy="2304288"/>
-        </p:xfrm>
-        <a:graphic>
-          <a:graphicData uri="http://schemas.openxmlformats.org/drawingml/2006/table">
-            <a:tbl>
-              <a:tblPr firstRow="1" bandRow="1">
-                <a:tableStyleId>{5C22544A-7EE6-4342-B048-85BDC9FD1C3A}</a:tableStyleId>
-              </a:tblPr>
-              <a:tblGrid>
-                <a:gridCol w="2704338"/>
-                <a:gridCol w="2704338"/>
-                <a:gridCol w="2704338"/>
-                <a:gridCol w="2704338"/>
-              </a:tblGrid>
-              <a:tr h="384048">
-                <a:tc>
-                  <a:txBody>
-                    <a:bodyPr/>
-                    <a:lstStyle/>
-                    <a:p>
-                      <a:r>
-                        <a:rPr sz="1100" b="1">
-                          <a:solidFill>
-                            <a:srgbClr val="FFFFFF"/>
-                          </a:solidFill>
-                          <a:latin typeface="Arial"/>
-                        </a:rPr>
-                        <a:t>Kennzahl</a:t>
-                      </a:r>
-                    </a:p>
-                  </a:txBody>
-                  <a:tcPr>
-                    <a:solidFill>
-                      <a:srgbClr val="1F2C56"/>
-                    </a:solidFill>
-                  </a:tcPr>
-                </a:tc>
-                <a:tc>
-                  <a:txBody>
-                    <a:bodyPr/>
-                    <a:lstStyle/>
-                    <a:p>
-                      <a:r>
-                        <a:rPr sz="1100" b="1">
-                          <a:solidFill>
-                            <a:srgbClr val="FFFFFF"/>
-                          </a:solidFill>
-                          <a:latin typeface="Arial"/>
-                        </a:rPr>
-                        <a:t>2024</a:t>
-                      </a:r>
-                    </a:p>
-                  </a:txBody>
-                  <a:tcPr>
-                    <a:solidFill>
-                      <a:srgbClr val="1F2C56"/>
-                    </a:solidFill>
-                  </a:tcPr>
-                </a:tc>
-                <a:tc>
-                  <a:txBody>
-                    <a:bodyPr/>
-                    <a:lstStyle/>
-                    <a:p>
-                      <a:r>
-                        <a:rPr sz="1100" b="1">
-                          <a:solidFill>
-                            <a:srgbClr val="FFFFFF"/>
-                          </a:solidFill>
-                          <a:latin typeface="Arial"/>
-                        </a:rPr>
-                        <a:t>2025</a:t>
-                      </a:r>
-                    </a:p>
-                  </a:txBody>
-                  <a:tcPr>
-                    <a:solidFill>
-                      <a:srgbClr val="1F2C56"/>
-                    </a:solidFill>
-                  </a:tcPr>
-                </a:tc>
-                <a:tc>
-                  <a:txBody>
-                    <a:bodyPr/>
-                    <a:lstStyle/>
-                    <a:p>
-                      <a:r>
-                        <a:rPr sz="1100" b="1">
-                          <a:solidFill>
-                            <a:srgbClr val="FFFFFF"/>
-                          </a:solidFill>
-                          <a:latin typeface="Arial"/>
-                        </a:rPr>
-                        <a:t>Branche (Ø)</a:t>
-                      </a:r>
-                    </a:p>
-                  </a:txBody>
-                  <a:tcPr>
-                    <a:solidFill>
-                      <a:srgbClr val="1F2C56"/>
-                    </a:solidFill>
-                  </a:tcPr>
-                </a:tc>
-              </a:tr>
-              <a:tr h="384048">
-                <a:tc>
-                  <a:txBody>
-                    <a:bodyPr/>
-                    <a:lstStyle/>
-                    <a:p>
-                      <a:r>
-                        <a:rPr sz="1050">
-                          <a:solidFill>
-                            <a:srgbClr val="3D5466"/>
-                          </a:solidFill>
-                          <a:latin typeface="Arial"/>
-                        </a:rPr>
-                        <a:t>Eigenkapitalquote</a:t>
-                      </a:r>
-                    </a:p>
-                  </a:txBody>
-                  <a:tcPr/>
-                </a:tc>
-                <a:tc>
-                  <a:txBody>
-                    <a:bodyPr/>
-                    <a:lstStyle/>
-                    <a:p>
-                      <a:r>
-                        <a:rPr sz="1050">
-                          <a:solidFill>
-                            <a:srgbClr val="3D5466"/>
-                          </a:solidFill>
-                          <a:latin typeface="Arial"/>
-                        </a:rPr>
-                        <a:t>22,4 %</a:t>
-                      </a:r>
-                    </a:p>
-                  </a:txBody>
-                  <a:tcPr/>
-                </a:tc>
-                <a:tc>
-                  <a:txBody>
-                    <a:bodyPr/>
-                    <a:lstStyle/>
-                    <a:p>
-                      <a:r>
-                        <a:rPr sz="1050">
-                          <a:solidFill>
-                            <a:srgbClr val="3D5466"/>
-                          </a:solidFill>
-                          <a:latin typeface="Arial"/>
-                        </a:rPr>
-                        <a:t>15,1 %</a:t>
-                      </a:r>
-                    </a:p>
-                  </a:txBody>
-                  <a:tcPr/>
-                </a:tc>
-                <a:tc>
-                  <a:txBody>
-                    <a:bodyPr/>
-                    <a:lstStyle/>
-                    <a:p>
-                      <a:r>
-                        <a:rPr sz="1050">
-                          <a:solidFill>
-                            <a:srgbClr val="3D5466"/>
-                          </a:solidFill>
-                          <a:latin typeface="Arial"/>
-                        </a:rPr>
-                        <a:t>28–32 %</a:t>
-                      </a:r>
-                    </a:p>
-                  </a:txBody>
-                  <a:tcPr/>
-                </a:tc>
-              </a:tr>
-              <a:tr h="384048">
-                <a:tc>
-                  <a:txBody>
-                    <a:bodyPr/>
-                    <a:lstStyle/>
-                    <a:p>
-                      <a:r>
-                        <a:rPr sz="1050">
-                          <a:solidFill>
-                            <a:srgbClr val="3D5466"/>
-                          </a:solidFill>
-                          <a:latin typeface="Arial"/>
-                        </a:rPr>
-                        <a:t>Liquidität 2. Grades</a:t>
-                      </a:r>
-                    </a:p>
-                  </a:txBody>
-                  <a:tcPr/>
-                </a:tc>
-                <a:tc>
-                  <a:txBody>
-                    <a:bodyPr/>
-                    <a:lstStyle/>
-                    <a:p>
-                      <a:r>
-                        <a:rPr sz="1050">
-                          <a:solidFill>
-                            <a:srgbClr val="3D5466"/>
-                          </a:solidFill>
-                          <a:latin typeface="Arial"/>
-                        </a:rPr>
-                        <a:t>1,18</a:t>
-                      </a:r>
-                    </a:p>
-                  </a:txBody>
-                  <a:tcPr/>
-                </a:tc>
-                <a:tc>
-                  <a:txBody>
-                    <a:bodyPr/>
-                    <a:lstStyle/>
-                    <a:p>
-                      <a:r>
-                        <a:rPr sz="1050">
-                          <a:solidFill>
-                            <a:srgbClr val="3D5466"/>
-                          </a:solidFill>
-                          <a:latin typeface="Arial"/>
-                        </a:rPr>
-                        <a:t>0,94</a:t>
-                      </a:r>
-                    </a:p>
-                  </a:txBody>
-                  <a:tcPr/>
-                </a:tc>
-                <a:tc>
-                  <a:txBody>
-                    <a:bodyPr/>
-                    <a:lstStyle/>
-                    <a:p>
-                      <a:r>
-                        <a:rPr sz="1050">
-                          <a:solidFill>
-                            <a:srgbClr val="3D5466"/>
-                          </a:solidFill>
-                          <a:latin typeface="Arial"/>
-                        </a:rPr>
-                        <a:t>&gt; 1,0</a:t>
-                      </a:r>
-                    </a:p>
-                  </a:txBody>
-                  <a:tcPr/>
-                </a:tc>
-              </a:tr>
-              <a:tr h="384048">
-                <a:tc>
-                  <a:txBody>
-                    <a:bodyPr/>
-                    <a:lstStyle/>
-                    <a:p>
-                      <a:r>
-                        <a:rPr sz="1050">
-                          <a:solidFill>
-                            <a:srgbClr val="3D5466"/>
-                          </a:solidFill>
-                          <a:latin typeface="Arial"/>
-                        </a:rPr>
-                        <a:t>Verschuldungsgrad (FK/EK)</a:t>
-                      </a:r>
-                    </a:p>
-                  </a:txBody>
-                  <a:tcPr/>
-                </a:tc>
-                <a:tc>
-                  <a:txBody>
-                    <a:bodyPr/>
-                    <a:lstStyle/>
-                    <a:p>
-                      <a:r>
-                        <a:rPr sz="1050">
-                          <a:solidFill>
-                            <a:srgbClr val="3D5466"/>
-                          </a:solidFill>
-                          <a:latin typeface="Arial"/>
-                        </a:rPr>
-                        <a:t>3,5x</a:t>
-                      </a:r>
-                    </a:p>
-                  </a:txBody>
-                  <a:tcPr/>
-                </a:tc>
-                <a:tc>
-                  <a:txBody>
-                    <a:bodyPr/>
-                    <a:lstStyle/>
-                    <a:p>
-                      <a:r>
-                        <a:rPr sz="1050">
-                          <a:solidFill>
-                            <a:srgbClr val="3D5466"/>
-                          </a:solidFill>
-                          <a:latin typeface="Arial"/>
-                        </a:rPr>
-                        <a:t>5,6x</a:t>
-                      </a:r>
-                    </a:p>
-                  </a:txBody>
-                  <a:tcPr/>
-                </a:tc>
-                <a:tc>
-                  <a:txBody>
-                    <a:bodyPr/>
-                    <a:lstStyle/>
-                    <a:p>
-                      <a:r>
-                        <a:rPr sz="1050">
-                          <a:solidFill>
-                            <a:srgbClr val="3D5466"/>
-                          </a:solidFill>
-                          <a:latin typeface="Arial"/>
-                        </a:rPr>
-                        <a:t>2,5–3,5x</a:t>
-                      </a:r>
-                    </a:p>
-                  </a:txBody>
-                  <a:tcPr/>
-                </a:tc>
-              </a:tr>
-              <a:tr h="384048">
-                <a:tc>
-                  <a:txBody>
-                    <a:bodyPr/>
-                    <a:lstStyle/>
-                    <a:p>
-                      <a:r>
-                        <a:rPr sz="1050">
-                          <a:solidFill>
-                            <a:srgbClr val="3D5466"/>
-                          </a:solidFill>
-                          <a:latin typeface="Arial"/>
-                        </a:rPr>
-                        <a:t>EBIT-Marge</a:t>
-                      </a:r>
-                    </a:p>
-                  </a:txBody>
-                  <a:tcPr/>
-                </a:tc>
-                <a:tc>
-                  <a:txBody>
-                    <a:bodyPr/>
-                    <a:lstStyle/>
-                    <a:p>
-                      <a:r>
-                        <a:rPr sz="1050">
-                          <a:solidFill>
-                            <a:srgbClr val="3D5466"/>
-                          </a:solidFill>
-                          <a:latin typeface="Arial"/>
-                        </a:rPr>
-                        <a:t>4,1 %</a:t>
-                      </a:r>
-                    </a:p>
-                  </a:txBody>
-                  <a:tcPr/>
-                </a:tc>
-                <a:tc>
-                  <a:txBody>
-                    <a:bodyPr/>
-                    <a:lstStyle/>
-                    <a:p>
-                      <a:r>
-                        <a:rPr sz="1050">
-                          <a:solidFill>
-                            <a:srgbClr val="3D5466"/>
-                          </a:solidFill>
-                          <a:latin typeface="Arial"/>
-                        </a:rPr>
-                        <a:t>2,8 %</a:t>
-                      </a:r>
-                    </a:p>
-                  </a:txBody>
-                  <a:tcPr/>
-                </a:tc>
-                <a:tc>
-                  <a:txBody>
-                    <a:bodyPr/>
-                    <a:lstStyle/>
-                    <a:p>
-                      <a:r>
-                        <a:rPr sz="1050">
-                          <a:solidFill>
-                            <a:srgbClr val="3D5466"/>
-                          </a:solidFill>
-                          <a:latin typeface="Arial"/>
-                        </a:rPr>
-                        <a:t>4–6 %</a:t>
-                      </a:r>
-                    </a:p>
-                  </a:txBody>
-                  <a:tcPr/>
-                </a:tc>
-              </a:tr>
-              <a:tr h="384048">
-                <a:tc>
-                  <a:txBody>
-                    <a:bodyPr/>
-                    <a:lstStyle/>
-                    <a:p>
-                      <a:r>
-                        <a:rPr sz="1050">
-                          <a:solidFill>
-                            <a:srgbClr val="3D5466"/>
-                          </a:solidFill>
-                          <a:latin typeface="Arial"/>
-                        </a:rPr>
-                        <a:t>Personalaufwandsquote</a:t>
-                      </a:r>
-                    </a:p>
-                  </a:txBody>
-                  <a:tcPr/>
-                </a:tc>
-                <a:tc>
-                  <a:txBody>
-                    <a:bodyPr/>
-                    <a:lstStyle/>
-                    <a:p>
-                      <a:r>
-                        <a:rPr sz="1050">
-                          <a:solidFill>
-                            <a:srgbClr val="3D5466"/>
-                          </a:solidFill>
-                          <a:latin typeface="Arial"/>
-                        </a:rPr>
-                        <a:t>38 %</a:t>
-                      </a:r>
-                    </a:p>
-                  </a:txBody>
-                  <a:tcPr/>
-                </a:tc>
-                <a:tc>
-                  <a:txBody>
-                    <a:bodyPr/>
-                    <a:lstStyle/>
-                    <a:p>
-                      <a:r>
-                        <a:rPr sz="1050">
-                          <a:solidFill>
-                            <a:srgbClr val="3D5466"/>
-                          </a:solidFill>
-                          <a:latin typeface="Arial"/>
-                        </a:rPr>
-                        <a:t>44 %</a:t>
-                      </a:r>
-                    </a:p>
-                  </a:txBody>
-                  <a:tcPr/>
-                </a:tc>
-                <a:tc>
-                  <a:txBody>
-                    <a:bodyPr/>
-                    <a:lstStyle/>
-                    <a:p>
-                      <a:r>
-                        <a:rPr sz="1050">
-                          <a:solidFill>
-                            <a:srgbClr val="3D5466"/>
-                          </a:solidFill>
-                          <a:latin typeface="Arial"/>
-                        </a:rPr>
-                        <a:t>38–42 %</a:t>
-                      </a:r>
-                    </a:p>
-                  </a:txBody>
-                  <a:tcPr/>
-                </a:tc>
-              </a:tr>
-            </a:tbl>
-          </a:graphicData>
-        </a:graphic>
-      </p:graphicFrame>
+      <p:pic>
+        <p:nvPicPr>
+          <p:cNvPr id="7" name="Picture 6" descr="image.png"/>
+          <p:cNvPicPr>
+            <a:picLocks noChangeAspect="1"/>
+          </p:cNvPicPr>
+          <p:nvPr/>
+        </p:nvPicPr>
+        <p:blipFill>
+          <a:blip r:embed="rId2"/>
+          <a:stretch>
+            <a:fillRect/>
+          </a:stretch>
+        </p:blipFill>
+        <p:spPr>
+          <a:xfrm>
+            <a:off x="1670951" y="1325880"/>
+            <a:ext cx="8847050" cy="4937760"/>
+          </a:xfrm>
+          <a:prstGeom prst="rect">
+            <a:avLst/>
+          </a:prstGeom>
+        </p:spPr>
+      </p:pic>
       <p:sp>
         <p:nvSpPr>
           <p:cNvPr id="8" name="Rectangle 7"/>
@@ -10150,7 +9520,7 @@
                 </a:solidFill>
                 <a:latin typeface="Consolas"/>
               </a:rPr>
-              <a:t>Übersicht</a:t>
+              <a:t>Schaubild</a:t>
             </a:r>
           </a:p>
         </p:txBody>

</xml_diff>